<commit_message>
Replace schematic stitch drawings with original 3D suture figures.
Named-pattern slides now carry photoreal teaching stills (skin pad, dermis cutaway, viscus, purse-string) instead of X-mark schematics. Vertical mattress is a constructed original on the same pad. Forty slides, Hall type, and Week 8 / no-harvest rules stay in place.

Co-authored-by: drkimvet <drkimvet@users.noreply.github.com>
</commit_message>
<xml_diff>
--- a/lectures/DVM-612_Week7_Suture_Patterns_Closures.pptx
+++ b/lectures/DVM-612_Week7_Suture_Patterns_Closures.pptx
@@ -1241,7 +1241,7 @@
           <a:lstStyle/>
           <a:p>
             <a:r>
-              <a:t>WCVM: interrupted, appositional, normal tension. Minimal blood-supply hit unless overtightened.</a:t>
+              <a:t>WCVM: interrupted, appositional, normal tension. Minimal blood-supply hit unless overtightened. The figure is original 3D teaching art, not a Fossum plate.</a:t>
             </a:r>
           </a:p>
         </p:txBody>
@@ -1381,7 +1381,7 @@
           <a:lstStyle/>
           <a:p>
             <a:r>
-              <a:t>Exam trap: one knot failure opens the line.</a:t>
+              <a:t>Exam trap: one knot failure opens the line. Original 3D figure.</a:t>
             </a:r>
           </a:p>
         </p:txBody>
@@ -1451,7 +1451,7 @@
           <a:lstStyle/>
           <a:p>
             <a:r>
-              <a:t>Students love this one. Make them leave it loose.</a:t>
+              <a:t>Students love this one. Make them leave it loose. Original 3D figure.</a:t>
             </a:r>
           </a:p>
         </p:txBody>
@@ -1521,7 +1521,7 @@
           <a:lstStyle/>
           <a:p>
             <a:r>
-              <a:t>Merck: mattress transfers tension off the edge. WCVM: major ischemia if tight.</a:t>
+              <a:t>Merck: mattress transfers tension off the edge. WCVM: major ischemia if tight. Original 3D figure.</a:t>
             </a:r>
           </a:p>
         </p:txBody>
@@ -1591,7 +1591,7 @@
           <a:lstStyle/>
           <a:p>
             <a:r>
-              <a:t>Say far-far near-near twice. That is the exam phrase.</a:t>
+              <a:t>Say far-far near-near twice. That is the exam phrase. Original 3D figure: surface bars on each side of the cut.</a:t>
             </a:r>
           </a:p>
         </p:txBody>
@@ -1661,7 +1661,7 @@
           <a:lstStyle/>
           <a:p>
             <a:r>
-              <a:t>Do not spend five minutes on the order variants. Name the idea.</a:t>
+              <a:t>Do not spend five minutes on the order variants. Name the idea. Original 3D figure.</a:t>
             </a:r>
           </a:p>
         </p:txBody>
@@ -1731,7 +1731,7 @@
           <a:lstStyle/>
           <a:p>
             <a:r>
-              <a:t>Field and large-animal students will see this again in Week 13. Same three questions.</a:t>
+              <a:t>Field and large-animal students will see this again in Week 13. Same three questions. Original 3D figure.</a:t>
             </a:r>
           </a:p>
         </p:txBody>
@@ -1801,7 +1801,7 @@
           <a:lstStyle/>
           <a:p>
             <a:r>
-              <a:t>Students will want this on every spay. Make them earn a quiet dermis first.</a:t>
+              <a:t>Students will want this on every spay. Make them earn a quiet dermis first. Original 3D cutaway.</a:t>
             </a:r>
           </a:p>
         </p:txBody>
@@ -1871,7 +1871,7 @@
           <a:lstStyle/>
           <a:p>
             <a:r>
-              <a:t>Do not invent a GI size table. Name layers: no mucosa.</a:t>
+              <a:t>Do not invent a GI size table. Name layers: no mucosa. Original 3D viscus figure.</a:t>
             </a:r>
           </a:p>
         </p:txBody>
@@ -1941,7 +1941,7 @@
           <a:lstStyle/>
           <a:p>
             <a:r>
-              <a:t>This is the highest-yield viscus pair. Repeat the mnemonic once. Do not invent which organ prefers which.</a:t>
+              <a:t>This is the highest-yield viscus pair. Repeat the mnemonic once. Connell figure shows full-thickness bites into the lumen. Do not invent which organ prefers which.</a:t>
             </a:r>
           </a:p>
         </p:txBody>
@@ -2011,7 +2011,7 @@
           <a:lstStyle/>
           <a:p>
             <a:r>
-              <a:t>Do not perform a purse-string demo with invented bite counts.</a:t>
+              <a:t>Do not perform a purse-string demo with invented bite counts. Original 3D figure.</a:t>
             </a:r>
           </a:p>
         </p:txBody>
@@ -13589,7 +13589,7 @@
         <p:spPr>
           <a:xfrm>
             <a:off x="365760" y="1051560"/>
-            <a:ext cx="5212080" cy="384048"/>
+            <a:ext cx="5212080" cy="365760"/>
           </a:xfrm>
           <a:prstGeom prst="rect">
             <a:avLst/>
@@ -13632,7 +13632,7 @@
         <p:spPr>
           <a:xfrm>
             <a:off x="365760" y="1051560"/>
-            <a:ext cx="5212080" cy="384048"/>
+            <a:ext cx="5212080" cy="365760"/>
           </a:xfrm>
           <a:prstGeom prst="rect">
             <a:avLst/>
@@ -13645,407 +13645,44 @@
           <a:p>
             <a:pPr algn="ctr"/>
             <a:r>
-              <a:rPr sz="1600" b="1">
+              <a:rPr sz="1400" b="1">
                 <a:solidFill>
                   <a:srgbClr val="C5A35A"/>
                 </a:solidFill>
                 <a:latin typeface="Calibri"/>
               </a:rPr>
-              <a:t>Schematic  ·  original</a:t>
-            </a:r>
-          </a:p>
-        </p:txBody>
-      </p:sp>
-      <p:sp>
-        <p:nvSpPr>
-          <p:cNvPr id="10" name="Rectangle 9"/>
-          <p:cNvSpPr/>
-          <p:nvPr/>
-        </p:nvSpPr>
-        <p:spPr>
-          <a:xfrm>
-            <a:off x="594360" y="2743200"/>
-            <a:ext cx="3108960" cy="36576"/>
-          </a:xfrm>
-          <a:prstGeom prst="rect">
-            <a:avLst/>
-          </a:prstGeom>
-          <a:solidFill>
-            <a:srgbClr val="0B2C4A"/>
-          </a:solidFill>
-          <a:ln>
-            <a:noFill/>
-          </a:ln>
-        </p:spPr>
-        <p:style>
-          <a:lnRef idx="1">
-            <a:schemeClr val="accent1"/>
-          </a:lnRef>
-          <a:fillRef idx="3">
-            <a:schemeClr val="accent1"/>
-          </a:fillRef>
-          <a:effectRef idx="2">
-            <a:schemeClr val="accent1"/>
-          </a:effectRef>
-          <a:fontRef idx="minor">
-            <a:schemeClr val="lt1"/>
-          </a:fontRef>
-        </p:style>
-        <p:txBody>
-          <a:bodyPr rtlCol="0" anchor="ctr"/>
-          <a:lstStyle/>
-          <a:p>
-            <a:pPr algn="ctr"/>
-          </a:p>
-        </p:txBody>
-      </p:sp>
-      <p:sp>
-        <p:nvSpPr>
-          <p:cNvPr id="11" name="Rectangle 10"/>
-          <p:cNvSpPr/>
-          <p:nvPr/>
-        </p:nvSpPr>
-        <p:spPr>
-          <a:xfrm>
-            <a:off x="813816" y="2761488"/>
-            <a:ext cx="201168" cy="32004"/>
-          </a:xfrm>
-          <a:prstGeom prst="rect">
-            <a:avLst/>
-          </a:prstGeom>
-          <a:solidFill>
-            <a:srgbClr val="C5A35A"/>
-          </a:solidFill>
-          <a:ln>
-            <a:noFill/>
-          </a:ln>
-        </p:spPr>
-        <p:style>
-          <a:lnRef idx="1">
-            <a:schemeClr val="accent1"/>
-          </a:lnRef>
-          <a:fillRef idx="3">
-            <a:schemeClr val="accent1"/>
-          </a:fillRef>
-          <a:effectRef idx="2">
-            <a:schemeClr val="accent1"/>
-          </a:effectRef>
-          <a:fontRef idx="minor">
-            <a:schemeClr val="lt1"/>
-          </a:fontRef>
-        </p:style>
-        <p:txBody>
-          <a:bodyPr rtlCol="0" anchor="ctr"/>
-          <a:lstStyle/>
-          <a:p>
-            <a:pPr algn="ctr"/>
-          </a:p>
-        </p:txBody>
-      </p:sp>
-      <p:sp>
-        <p:nvSpPr>
-          <p:cNvPr id="12" name="Rectangle 11"/>
-          <p:cNvSpPr/>
-          <p:nvPr/>
-        </p:nvSpPr>
-        <p:spPr>
-          <a:xfrm>
-            <a:off x="914400" y="2660904"/>
-            <a:ext cx="32004" cy="201168"/>
-          </a:xfrm>
-          <a:prstGeom prst="rect">
-            <a:avLst/>
-          </a:prstGeom>
-          <a:solidFill>
-            <a:srgbClr val="C5A35A"/>
-          </a:solidFill>
-          <a:ln>
-            <a:noFill/>
-          </a:ln>
-        </p:spPr>
-        <p:style>
-          <a:lnRef idx="1">
-            <a:schemeClr val="accent1"/>
-          </a:lnRef>
-          <a:fillRef idx="3">
-            <a:schemeClr val="accent1"/>
-          </a:fillRef>
-          <a:effectRef idx="2">
-            <a:schemeClr val="accent1"/>
-          </a:effectRef>
-          <a:fontRef idx="minor">
-            <a:schemeClr val="lt1"/>
-          </a:fontRef>
-        </p:style>
-        <p:txBody>
-          <a:bodyPr rtlCol="0" anchor="ctr"/>
-          <a:lstStyle/>
-          <a:p>
-            <a:pPr algn="ctr"/>
-          </a:p>
-        </p:txBody>
-      </p:sp>
-      <p:sp>
-        <p:nvSpPr>
-          <p:cNvPr id="13" name="Rectangle 12"/>
-          <p:cNvSpPr/>
-          <p:nvPr/>
-        </p:nvSpPr>
-        <p:spPr>
-          <a:xfrm>
-            <a:off x="1545336" y="2761488"/>
-            <a:ext cx="201168" cy="32004"/>
-          </a:xfrm>
-          <a:prstGeom prst="rect">
-            <a:avLst/>
-          </a:prstGeom>
-          <a:solidFill>
-            <a:srgbClr val="C5A35A"/>
-          </a:solidFill>
-          <a:ln>
-            <a:noFill/>
-          </a:ln>
-        </p:spPr>
-        <p:style>
-          <a:lnRef idx="1">
-            <a:schemeClr val="accent1"/>
-          </a:lnRef>
-          <a:fillRef idx="3">
-            <a:schemeClr val="accent1"/>
-          </a:fillRef>
-          <a:effectRef idx="2">
-            <a:schemeClr val="accent1"/>
-          </a:effectRef>
-          <a:fontRef idx="minor">
-            <a:schemeClr val="lt1"/>
-          </a:fontRef>
-        </p:style>
-        <p:txBody>
-          <a:bodyPr rtlCol="0" anchor="ctr"/>
-          <a:lstStyle/>
-          <a:p>
-            <a:pPr algn="ctr"/>
-          </a:p>
-        </p:txBody>
-      </p:sp>
-      <p:sp>
-        <p:nvSpPr>
-          <p:cNvPr id="14" name="Rectangle 13"/>
-          <p:cNvSpPr/>
-          <p:nvPr/>
-        </p:nvSpPr>
-        <p:spPr>
-          <a:xfrm>
-            <a:off x="1645920" y="2660904"/>
-            <a:ext cx="32004" cy="201168"/>
-          </a:xfrm>
-          <a:prstGeom prst="rect">
-            <a:avLst/>
-          </a:prstGeom>
-          <a:solidFill>
-            <a:srgbClr val="C5A35A"/>
-          </a:solidFill>
-          <a:ln>
-            <a:noFill/>
-          </a:ln>
-        </p:spPr>
-        <p:style>
-          <a:lnRef idx="1">
-            <a:schemeClr val="accent1"/>
-          </a:lnRef>
-          <a:fillRef idx="3">
-            <a:schemeClr val="accent1"/>
-          </a:fillRef>
-          <a:effectRef idx="2">
-            <a:schemeClr val="accent1"/>
-          </a:effectRef>
-          <a:fontRef idx="minor">
-            <a:schemeClr val="lt1"/>
-          </a:fontRef>
-        </p:style>
-        <p:txBody>
-          <a:bodyPr rtlCol="0" anchor="ctr"/>
-          <a:lstStyle/>
-          <a:p>
-            <a:pPr algn="ctr"/>
-          </a:p>
-        </p:txBody>
-      </p:sp>
-      <p:sp>
-        <p:nvSpPr>
-          <p:cNvPr id="15" name="Rectangle 14"/>
-          <p:cNvSpPr/>
-          <p:nvPr/>
-        </p:nvSpPr>
-        <p:spPr>
-          <a:xfrm>
-            <a:off x="2276856" y="2761488"/>
-            <a:ext cx="201168" cy="32004"/>
-          </a:xfrm>
-          <a:prstGeom prst="rect">
-            <a:avLst/>
-          </a:prstGeom>
-          <a:solidFill>
-            <a:srgbClr val="C5A35A"/>
-          </a:solidFill>
-          <a:ln>
-            <a:noFill/>
-          </a:ln>
-        </p:spPr>
-        <p:style>
-          <a:lnRef idx="1">
-            <a:schemeClr val="accent1"/>
-          </a:lnRef>
-          <a:fillRef idx="3">
-            <a:schemeClr val="accent1"/>
-          </a:fillRef>
-          <a:effectRef idx="2">
-            <a:schemeClr val="accent1"/>
-          </a:effectRef>
-          <a:fontRef idx="minor">
-            <a:schemeClr val="lt1"/>
-          </a:fontRef>
-        </p:style>
-        <p:txBody>
-          <a:bodyPr rtlCol="0" anchor="ctr"/>
-          <a:lstStyle/>
-          <a:p>
-            <a:pPr algn="ctr"/>
-          </a:p>
-        </p:txBody>
-      </p:sp>
-      <p:sp>
-        <p:nvSpPr>
-          <p:cNvPr id="16" name="Rectangle 15"/>
-          <p:cNvSpPr/>
-          <p:nvPr/>
-        </p:nvSpPr>
-        <p:spPr>
-          <a:xfrm>
-            <a:off x="2377440" y="2660904"/>
-            <a:ext cx="32004" cy="201168"/>
-          </a:xfrm>
-          <a:prstGeom prst="rect">
-            <a:avLst/>
-          </a:prstGeom>
-          <a:solidFill>
-            <a:srgbClr val="C5A35A"/>
-          </a:solidFill>
-          <a:ln>
-            <a:noFill/>
-          </a:ln>
-        </p:spPr>
-        <p:style>
-          <a:lnRef idx="1">
-            <a:schemeClr val="accent1"/>
-          </a:lnRef>
-          <a:fillRef idx="3">
-            <a:schemeClr val="accent1"/>
-          </a:fillRef>
-          <a:effectRef idx="2">
-            <a:schemeClr val="accent1"/>
-          </a:effectRef>
-          <a:fontRef idx="minor">
-            <a:schemeClr val="lt1"/>
-          </a:fontRef>
-        </p:style>
-        <p:txBody>
-          <a:bodyPr rtlCol="0" anchor="ctr"/>
-          <a:lstStyle/>
-          <a:p>
-            <a:pPr algn="ctr"/>
-          </a:p>
-        </p:txBody>
-      </p:sp>
-      <p:sp>
-        <p:nvSpPr>
-          <p:cNvPr id="17" name="Rectangle 16"/>
-          <p:cNvSpPr/>
-          <p:nvPr/>
-        </p:nvSpPr>
-        <p:spPr>
-          <a:xfrm>
-            <a:off x="3008376" y="2761488"/>
-            <a:ext cx="201168" cy="32004"/>
-          </a:xfrm>
-          <a:prstGeom prst="rect">
-            <a:avLst/>
-          </a:prstGeom>
-          <a:solidFill>
-            <a:srgbClr val="C5A35A"/>
-          </a:solidFill>
-          <a:ln>
-            <a:noFill/>
-          </a:ln>
-        </p:spPr>
-        <p:style>
-          <a:lnRef idx="1">
-            <a:schemeClr val="accent1"/>
-          </a:lnRef>
-          <a:fillRef idx="3">
-            <a:schemeClr val="accent1"/>
-          </a:fillRef>
-          <a:effectRef idx="2">
-            <a:schemeClr val="accent1"/>
-          </a:effectRef>
-          <a:fontRef idx="minor">
-            <a:schemeClr val="lt1"/>
-          </a:fontRef>
-        </p:style>
-        <p:txBody>
-          <a:bodyPr rtlCol="0" anchor="ctr"/>
-          <a:lstStyle/>
-          <a:p>
-            <a:pPr algn="ctr"/>
-          </a:p>
-        </p:txBody>
-      </p:sp>
-      <p:sp>
-        <p:nvSpPr>
-          <p:cNvPr id="18" name="Rectangle 17"/>
-          <p:cNvSpPr/>
-          <p:nvPr/>
-        </p:nvSpPr>
-        <p:spPr>
-          <a:xfrm>
-            <a:off x="3108960" y="2660904"/>
-            <a:ext cx="32004" cy="201168"/>
-          </a:xfrm>
-          <a:prstGeom prst="rect">
-            <a:avLst/>
-          </a:prstGeom>
-          <a:solidFill>
-            <a:srgbClr val="C5A35A"/>
-          </a:solidFill>
-          <a:ln>
-            <a:noFill/>
-          </a:ln>
-        </p:spPr>
-        <p:style>
-          <a:lnRef idx="1">
-            <a:schemeClr val="accent1"/>
-          </a:lnRef>
-          <a:fillRef idx="3">
-            <a:schemeClr val="accent1"/>
-          </a:fillRef>
-          <a:effectRef idx="2">
-            <a:schemeClr val="accent1"/>
-          </a:effectRef>
-          <a:fontRef idx="minor">
-            <a:schemeClr val="lt1"/>
-          </a:fontRef>
-        </p:style>
-        <p:txBody>
-          <a:bodyPr rtlCol="0" anchor="ctr"/>
-          <a:lstStyle/>
-          <a:p>
-            <a:pPr algn="ctr"/>
-          </a:p>
-        </p:txBody>
-      </p:sp>
-      <p:sp>
-        <p:nvSpPr>
-          <p:cNvPr id="19" name="Rounded Rectangle 18"/>
+              <a:t>Original 3D teaching figure</a:t>
+            </a:r>
+          </a:p>
+        </p:txBody>
+      </p:sp>
+      <p:pic>
+        <p:nvPicPr>
+          <p:cNvPr id="10" name="Picture 9" descr="suture3d_simple_interrupted.png"/>
+          <p:cNvPicPr>
+            <a:picLocks noChangeAspect="1"/>
+          </p:cNvPicPr>
+          <p:nvPr/>
+        </p:nvPicPr>
+        <p:blipFill>
+          <a:blip r:embed="rId2"/>
+          <a:stretch>
+            <a:fillRect/>
+          </a:stretch>
+        </p:blipFill>
+        <p:spPr>
+          <a:xfrm>
+            <a:off x="493776" y="1940814"/>
+            <a:ext cx="4956048" cy="3717036"/>
+          </a:xfrm>
+          <a:prstGeom prst="rect">
+            <a:avLst/>
+          </a:prstGeom>
+        </p:spPr>
+      </p:pic>
+      <p:sp>
+        <p:nvSpPr>
+          <p:cNvPr id="11" name="Rounded Rectangle 10"/>
           <p:cNvSpPr/>
           <p:nvPr/>
         </p:nvSpPr>
@@ -14090,7 +13727,7 @@
       </p:sp>
       <p:sp>
         <p:nvSpPr>
-          <p:cNvPr id="20" name="Rectangle 19"/>
+          <p:cNvPr id="12" name="Rectangle 11"/>
           <p:cNvSpPr/>
           <p:nvPr/>
         </p:nvSpPr>
@@ -14133,7 +13770,7 @@
       </p:sp>
       <p:sp>
         <p:nvSpPr>
-          <p:cNvPr id="21" name="TextBox 20"/>
+          <p:cNvPr id="13" name="TextBox 12"/>
           <p:cNvSpPr txBox="1"/>
           <p:nvPr/>
         </p:nvSpPr>
@@ -14166,7 +13803,7 @@
       </p:sp>
       <p:sp>
         <p:nvSpPr>
-          <p:cNvPr id="22" name="TextBox 21"/>
+          <p:cNvPr id="14" name="TextBox 13"/>
           <p:cNvSpPr txBox="1"/>
           <p:nvPr/>
         </p:nvSpPr>
@@ -14203,7 +13840,7 @@
       </p:sp>
       <p:sp>
         <p:nvSpPr>
-          <p:cNvPr id="23" name="Rectangle 22"/>
+          <p:cNvPr id="15" name="Rectangle 14"/>
           <p:cNvSpPr/>
           <p:nvPr/>
         </p:nvSpPr>
@@ -14246,7 +13883,7 @@
       </p:sp>
       <p:sp>
         <p:nvSpPr>
-          <p:cNvPr id="24" name="TextBox 23"/>
+          <p:cNvPr id="16" name="TextBox 15"/>
           <p:cNvSpPr txBox="1"/>
           <p:nvPr/>
         </p:nvSpPr>
@@ -14279,7 +13916,7 @@
       </p:sp>
       <p:sp>
         <p:nvSpPr>
-          <p:cNvPr id="25" name="TextBox 24"/>
+          <p:cNvPr id="17" name="TextBox 16"/>
           <p:cNvSpPr txBox="1"/>
           <p:nvPr/>
         </p:nvSpPr>
@@ -15100,7 +14737,7 @@
         <p:spPr>
           <a:xfrm>
             <a:off x="365760" y="1051560"/>
-            <a:ext cx="5212080" cy="384048"/>
+            <a:ext cx="5212080" cy="365760"/>
           </a:xfrm>
           <a:prstGeom prst="rect">
             <a:avLst/>
@@ -15143,7 +14780,7 @@
         <p:spPr>
           <a:xfrm>
             <a:off x="365760" y="1051560"/>
-            <a:ext cx="5212080" cy="384048"/>
+            <a:ext cx="5212080" cy="365760"/>
           </a:xfrm>
           <a:prstGeom prst="rect">
             <a:avLst/>
@@ -15156,106 +14793,44 @@
           <a:p>
             <a:pPr algn="ctr"/>
             <a:r>
-              <a:rPr sz="1600" b="1">
+              <a:rPr sz="1400" b="1">
                 <a:solidFill>
                   <a:srgbClr val="C5A35A"/>
                 </a:solidFill>
                 <a:latin typeface="Calibri"/>
               </a:rPr>
-              <a:t>Schematic  ·  original</a:t>
-            </a:r>
-          </a:p>
-        </p:txBody>
-      </p:sp>
-      <p:sp>
-        <p:nvSpPr>
-          <p:cNvPr id="10" name="Rectangle 9"/>
-          <p:cNvSpPr/>
-          <p:nvPr/>
-        </p:nvSpPr>
-        <p:spPr>
-          <a:xfrm>
-            <a:off x="594360" y="2743200"/>
-            <a:ext cx="3108960" cy="36576"/>
-          </a:xfrm>
-          <a:prstGeom prst="rect">
-            <a:avLst/>
-          </a:prstGeom>
-          <a:solidFill>
-            <a:srgbClr val="0B2C4A"/>
-          </a:solidFill>
-          <a:ln>
-            <a:noFill/>
-          </a:ln>
-        </p:spPr>
-        <p:style>
-          <a:lnRef idx="1">
-            <a:schemeClr val="accent1"/>
-          </a:lnRef>
-          <a:fillRef idx="3">
-            <a:schemeClr val="accent1"/>
-          </a:fillRef>
-          <a:effectRef idx="2">
-            <a:schemeClr val="accent1"/>
-          </a:effectRef>
-          <a:fontRef idx="minor">
-            <a:schemeClr val="lt1"/>
-          </a:fontRef>
-        </p:style>
-        <p:txBody>
-          <a:bodyPr rtlCol="0" anchor="ctr"/>
-          <a:lstStyle/>
-          <a:p>
-            <a:pPr algn="ctr"/>
-          </a:p>
-        </p:txBody>
-      </p:sp>
-      <p:sp>
-        <p:nvSpPr>
-          <p:cNvPr id="11" name="Rectangle 10"/>
-          <p:cNvSpPr/>
-          <p:nvPr/>
-        </p:nvSpPr>
-        <p:spPr>
-          <a:xfrm>
-            <a:off x="777240" y="2606040"/>
-            <a:ext cx="2834640" cy="54864"/>
-          </a:xfrm>
-          <a:prstGeom prst="rect">
-            <a:avLst/>
-          </a:prstGeom>
-          <a:solidFill>
-            <a:srgbClr val="C5A35A"/>
-          </a:solidFill>
-          <a:ln>
-            <a:noFill/>
-          </a:ln>
-        </p:spPr>
-        <p:style>
-          <a:lnRef idx="1">
-            <a:schemeClr val="accent1"/>
-          </a:lnRef>
-          <a:fillRef idx="3">
-            <a:schemeClr val="accent1"/>
-          </a:fillRef>
-          <a:effectRef idx="2">
-            <a:schemeClr val="accent1"/>
-          </a:effectRef>
-          <a:fontRef idx="minor">
-            <a:schemeClr val="lt1"/>
-          </a:fontRef>
-        </p:style>
-        <p:txBody>
-          <a:bodyPr rtlCol="0" anchor="ctr"/>
-          <a:lstStyle/>
-          <a:p>
-            <a:pPr algn="ctr"/>
-          </a:p>
-        </p:txBody>
-      </p:sp>
-      <p:sp>
-        <p:nvSpPr>
-          <p:cNvPr id="12" name="Rounded Rectangle 11"/>
+              <a:t>Original 3D teaching figure</a:t>
+            </a:r>
+          </a:p>
+        </p:txBody>
+      </p:sp>
+      <p:pic>
+        <p:nvPicPr>
+          <p:cNvPr id="10" name="Picture 9" descr="suture3d_simple_continuous.png"/>
+          <p:cNvPicPr>
+            <a:picLocks noChangeAspect="1"/>
+          </p:cNvPicPr>
+          <p:nvPr/>
+        </p:nvPicPr>
+        <p:blipFill>
+          <a:blip r:embed="rId2"/>
+          <a:stretch>
+            <a:fillRect/>
+          </a:stretch>
+        </p:blipFill>
+        <p:spPr>
+          <a:xfrm>
+            <a:off x="493776" y="1940814"/>
+            <a:ext cx="4956048" cy="3717036"/>
+          </a:xfrm>
+          <a:prstGeom prst="rect">
+            <a:avLst/>
+          </a:prstGeom>
+        </p:spPr>
+      </p:pic>
+      <p:sp>
+        <p:nvSpPr>
+          <p:cNvPr id="11" name="Rounded Rectangle 10"/>
           <p:cNvSpPr/>
           <p:nvPr/>
         </p:nvSpPr>
@@ -15300,7 +14875,7 @@
       </p:sp>
       <p:sp>
         <p:nvSpPr>
-          <p:cNvPr id="13" name="Rectangle 12"/>
+          <p:cNvPr id="12" name="Rectangle 11"/>
           <p:cNvSpPr/>
           <p:nvPr/>
         </p:nvSpPr>
@@ -15343,7 +14918,7 @@
       </p:sp>
       <p:sp>
         <p:nvSpPr>
-          <p:cNvPr id="14" name="TextBox 13"/>
+          <p:cNvPr id="13" name="TextBox 12"/>
           <p:cNvSpPr txBox="1"/>
           <p:nvPr/>
         </p:nvSpPr>
@@ -15376,7 +14951,7 @@
       </p:sp>
       <p:sp>
         <p:nvSpPr>
-          <p:cNvPr id="15" name="TextBox 14"/>
+          <p:cNvPr id="14" name="TextBox 13"/>
           <p:cNvSpPr txBox="1"/>
           <p:nvPr/>
         </p:nvSpPr>
@@ -15413,7 +14988,7 @@
       </p:sp>
       <p:sp>
         <p:nvSpPr>
-          <p:cNvPr id="16" name="Rectangle 15"/>
+          <p:cNvPr id="15" name="Rectangle 14"/>
           <p:cNvSpPr/>
           <p:nvPr/>
         </p:nvSpPr>
@@ -15456,7 +15031,7 @@
       </p:sp>
       <p:sp>
         <p:nvSpPr>
-          <p:cNvPr id="17" name="TextBox 16"/>
+          <p:cNvPr id="16" name="TextBox 15"/>
           <p:cNvSpPr txBox="1"/>
           <p:nvPr/>
         </p:nvSpPr>
@@ -15489,7 +15064,7 @@
       </p:sp>
       <p:sp>
         <p:nvSpPr>
-          <p:cNvPr id="18" name="TextBox 17"/>
+          <p:cNvPr id="17" name="TextBox 16"/>
           <p:cNvSpPr txBox="1"/>
           <p:nvPr/>
         </p:nvSpPr>
@@ -15797,7 +15372,7 @@
         <p:spPr>
           <a:xfrm>
             <a:off x="365760" y="1051560"/>
-            <a:ext cx="5212080" cy="384048"/>
+            <a:ext cx="5212080" cy="365760"/>
           </a:xfrm>
           <a:prstGeom prst="rect">
             <a:avLst/>
@@ -15840,7 +15415,7 @@
         <p:spPr>
           <a:xfrm>
             <a:off x="365760" y="1051560"/>
-            <a:ext cx="5212080" cy="384048"/>
+            <a:ext cx="5212080" cy="365760"/>
           </a:xfrm>
           <a:prstGeom prst="rect">
             <a:avLst/>
@@ -15853,235 +15428,44 @@
           <a:p>
             <a:pPr algn="ctr"/>
             <a:r>
-              <a:rPr sz="1600" b="1">
+              <a:rPr sz="1400" b="1">
                 <a:solidFill>
                   <a:srgbClr val="C5A35A"/>
                 </a:solidFill>
                 <a:latin typeface="Calibri"/>
               </a:rPr>
-              <a:t>Schematic  ·  original</a:t>
-            </a:r>
-          </a:p>
-        </p:txBody>
-      </p:sp>
-      <p:sp>
-        <p:nvSpPr>
-          <p:cNvPr id="10" name="Rectangle 9"/>
-          <p:cNvSpPr/>
-          <p:nvPr/>
-        </p:nvSpPr>
-        <p:spPr>
-          <a:xfrm>
-            <a:off x="594360" y="2788920"/>
-            <a:ext cx="3108960" cy="36576"/>
-          </a:xfrm>
-          <a:prstGeom prst="rect">
-            <a:avLst/>
-          </a:prstGeom>
-          <a:solidFill>
-            <a:srgbClr val="0B2C4A"/>
-          </a:solidFill>
-          <a:ln>
-            <a:noFill/>
-          </a:ln>
-        </p:spPr>
-        <p:style>
-          <a:lnRef idx="1">
-            <a:schemeClr val="accent1"/>
-          </a:lnRef>
-          <a:fillRef idx="3">
-            <a:schemeClr val="accent1"/>
-          </a:fillRef>
-          <a:effectRef idx="2">
-            <a:schemeClr val="accent1"/>
-          </a:effectRef>
-          <a:fontRef idx="minor">
-            <a:schemeClr val="lt1"/>
-          </a:fontRef>
-        </p:style>
-        <p:txBody>
-          <a:bodyPr rtlCol="0" anchor="ctr"/>
-          <a:lstStyle/>
-          <a:p>
-            <a:pPr algn="ctr"/>
-          </a:p>
-        </p:txBody>
-      </p:sp>
-      <p:sp>
-        <p:nvSpPr>
-          <p:cNvPr id="11" name="Rectangle 10"/>
-          <p:cNvSpPr/>
-          <p:nvPr/>
-        </p:nvSpPr>
-        <p:spPr>
-          <a:xfrm>
-            <a:off x="1348740" y="2807208"/>
-            <a:ext cx="502920" cy="32004"/>
-          </a:xfrm>
-          <a:prstGeom prst="rect">
-            <a:avLst/>
-          </a:prstGeom>
-          <a:solidFill>
-            <a:srgbClr val="C5A35A"/>
-          </a:solidFill>
-          <a:ln>
-            <a:noFill/>
-          </a:ln>
-        </p:spPr>
-        <p:style>
-          <a:lnRef idx="1">
-            <a:schemeClr val="accent1"/>
-          </a:lnRef>
-          <a:fillRef idx="3">
-            <a:schemeClr val="accent1"/>
-          </a:fillRef>
-          <a:effectRef idx="2">
-            <a:schemeClr val="accent1"/>
-          </a:effectRef>
-          <a:fontRef idx="minor">
-            <a:schemeClr val="lt1"/>
-          </a:fontRef>
-        </p:style>
-        <p:txBody>
-          <a:bodyPr rtlCol="0" anchor="ctr"/>
-          <a:lstStyle/>
-          <a:p>
-            <a:pPr algn="ctr"/>
-          </a:p>
-        </p:txBody>
-      </p:sp>
-      <p:sp>
-        <p:nvSpPr>
-          <p:cNvPr id="12" name="Rectangle 11"/>
-          <p:cNvSpPr/>
-          <p:nvPr/>
-        </p:nvSpPr>
-        <p:spPr>
-          <a:xfrm>
-            <a:off x="1600200" y="2555748"/>
-            <a:ext cx="32004" cy="502920"/>
-          </a:xfrm>
-          <a:prstGeom prst="rect">
-            <a:avLst/>
-          </a:prstGeom>
-          <a:solidFill>
-            <a:srgbClr val="C5A35A"/>
-          </a:solidFill>
-          <a:ln>
-            <a:noFill/>
-          </a:ln>
-        </p:spPr>
-        <p:style>
-          <a:lnRef idx="1">
-            <a:schemeClr val="accent1"/>
-          </a:lnRef>
-          <a:fillRef idx="3">
-            <a:schemeClr val="accent1"/>
-          </a:fillRef>
-          <a:effectRef idx="2">
-            <a:schemeClr val="accent1"/>
-          </a:effectRef>
-          <a:fontRef idx="minor">
-            <a:schemeClr val="lt1"/>
-          </a:fontRef>
-        </p:style>
-        <p:txBody>
-          <a:bodyPr rtlCol="0" anchor="ctr"/>
-          <a:lstStyle/>
-          <a:p>
-            <a:pPr algn="ctr"/>
-          </a:p>
-        </p:txBody>
-      </p:sp>
-      <p:sp>
-        <p:nvSpPr>
-          <p:cNvPr id="13" name="Rectangle 12"/>
-          <p:cNvSpPr/>
-          <p:nvPr/>
-        </p:nvSpPr>
-        <p:spPr>
-          <a:xfrm>
-            <a:off x="2354580" y="2807208"/>
-            <a:ext cx="502920" cy="32004"/>
-          </a:xfrm>
-          <a:prstGeom prst="rect">
-            <a:avLst/>
-          </a:prstGeom>
-          <a:solidFill>
-            <a:srgbClr val="C5A35A"/>
-          </a:solidFill>
-          <a:ln>
-            <a:noFill/>
-          </a:ln>
-        </p:spPr>
-        <p:style>
-          <a:lnRef idx="1">
-            <a:schemeClr val="accent1"/>
-          </a:lnRef>
-          <a:fillRef idx="3">
-            <a:schemeClr val="accent1"/>
-          </a:fillRef>
-          <a:effectRef idx="2">
-            <a:schemeClr val="accent1"/>
-          </a:effectRef>
-          <a:fontRef idx="minor">
-            <a:schemeClr val="lt1"/>
-          </a:fontRef>
-        </p:style>
-        <p:txBody>
-          <a:bodyPr rtlCol="0" anchor="ctr"/>
-          <a:lstStyle/>
-          <a:p>
-            <a:pPr algn="ctr"/>
-          </a:p>
-        </p:txBody>
-      </p:sp>
-      <p:sp>
-        <p:nvSpPr>
-          <p:cNvPr id="14" name="Rectangle 13"/>
-          <p:cNvSpPr/>
-          <p:nvPr/>
-        </p:nvSpPr>
-        <p:spPr>
-          <a:xfrm>
-            <a:off x="2606040" y="2555748"/>
-            <a:ext cx="32004" cy="502920"/>
-          </a:xfrm>
-          <a:prstGeom prst="rect">
-            <a:avLst/>
-          </a:prstGeom>
-          <a:solidFill>
-            <a:srgbClr val="C5A35A"/>
-          </a:solidFill>
-          <a:ln>
-            <a:noFill/>
-          </a:ln>
-        </p:spPr>
-        <p:style>
-          <a:lnRef idx="1">
-            <a:schemeClr val="accent1"/>
-          </a:lnRef>
-          <a:fillRef idx="3">
-            <a:schemeClr val="accent1"/>
-          </a:fillRef>
-          <a:effectRef idx="2">
-            <a:schemeClr val="accent1"/>
-          </a:effectRef>
-          <a:fontRef idx="minor">
-            <a:schemeClr val="lt1"/>
-          </a:fontRef>
-        </p:style>
-        <p:txBody>
-          <a:bodyPr rtlCol="0" anchor="ctr"/>
-          <a:lstStyle/>
-          <a:p>
-            <a:pPr algn="ctr"/>
-          </a:p>
-        </p:txBody>
-      </p:sp>
-      <p:sp>
-        <p:nvSpPr>
-          <p:cNvPr id="15" name="Rounded Rectangle 14"/>
+              <a:t>Original 3D teaching figure</a:t>
+            </a:r>
+          </a:p>
+        </p:txBody>
+      </p:sp>
+      <p:pic>
+        <p:nvPicPr>
+          <p:cNvPr id="10" name="Picture 9" descr="suture3d_cruciate.png"/>
+          <p:cNvPicPr>
+            <a:picLocks noChangeAspect="1"/>
+          </p:cNvPicPr>
+          <p:nvPr/>
+        </p:nvPicPr>
+        <p:blipFill>
+          <a:blip r:embed="rId2"/>
+          <a:stretch>
+            <a:fillRect/>
+          </a:stretch>
+        </p:blipFill>
+        <p:spPr>
+          <a:xfrm>
+            <a:off x="493776" y="1940814"/>
+            <a:ext cx="4956048" cy="3717036"/>
+          </a:xfrm>
+          <a:prstGeom prst="rect">
+            <a:avLst/>
+          </a:prstGeom>
+        </p:spPr>
+      </p:pic>
+      <p:sp>
+        <p:nvSpPr>
+          <p:cNvPr id="11" name="Rounded Rectangle 10"/>
           <p:cNvSpPr/>
           <p:nvPr/>
         </p:nvSpPr>
@@ -16126,7 +15510,7 @@
       </p:sp>
       <p:sp>
         <p:nvSpPr>
-          <p:cNvPr id="16" name="Rectangle 15"/>
+          <p:cNvPr id="12" name="Rectangle 11"/>
           <p:cNvSpPr/>
           <p:nvPr/>
         </p:nvSpPr>
@@ -16169,7 +15553,7 @@
       </p:sp>
       <p:sp>
         <p:nvSpPr>
-          <p:cNvPr id="17" name="TextBox 16"/>
+          <p:cNvPr id="13" name="TextBox 12"/>
           <p:cNvSpPr txBox="1"/>
           <p:nvPr/>
         </p:nvSpPr>
@@ -16202,7 +15586,7 @@
       </p:sp>
       <p:sp>
         <p:nvSpPr>
-          <p:cNvPr id="18" name="TextBox 17"/>
+          <p:cNvPr id="14" name="TextBox 13"/>
           <p:cNvSpPr txBox="1"/>
           <p:nvPr/>
         </p:nvSpPr>
@@ -16239,7 +15623,7 @@
       </p:sp>
       <p:sp>
         <p:nvSpPr>
-          <p:cNvPr id="19" name="Rectangle 18"/>
+          <p:cNvPr id="15" name="Rectangle 14"/>
           <p:cNvSpPr/>
           <p:nvPr/>
         </p:nvSpPr>
@@ -16282,7 +15666,7 @@
       </p:sp>
       <p:sp>
         <p:nvSpPr>
-          <p:cNvPr id="20" name="TextBox 19"/>
+          <p:cNvPr id="16" name="TextBox 15"/>
           <p:cNvSpPr txBox="1"/>
           <p:nvPr/>
         </p:nvSpPr>
@@ -16315,7 +15699,7 @@
       </p:sp>
       <p:sp>
         <p:nvSpPr>
-          <p:cNvPr id="21" name="TextBox 20"/>
+          <p:cNvPr id="17" name="TextBox 16"/>
           <p:cNvSpPr txBox="1"/>
           <p:nvPr/>
         </p:nvSpPr>
@@ -16577,8 +15961,8 @@
         </p:nvSpPr>
         <p:spPr>
           <a:xfrm>
-            <a:off x="411480" y="1097280"/>
-            <a:ext cx="5623560" cy="5120640"/>
+            <a:off x="365760" y="1051560"/>
+            <a:ext cx="5212080" cy="5166360"/>
           </a:xfrm>
           <a:prstGeom prst="roundRect">
             <a:avLst>
@@ -16622,14 +16006,14 @@
         </p:nvSpPr>
         <p:spPr>
           <a:xfrm>
-            <a:off x="411480" y="1097280"/>
-            <a:ext cx="91440" cy="5120640"/>
-          </a:xfrm>
-          <a:prstGeom prst="rect">
-            <a:avLst/>
-          </a:prstGeom>
-          <a:solidFill>
-            <a:srgbClr val="C5A35A"/>
+            <a:off x="365760" y="1051560"/>
+            <a:ext cx="5212080" cy="365760"/>
+          </a:xfrm>
+          <a:prstGeom prst="rect">
+            <a:avLst/>
+          </a:prstGeom>
+          <a:solidFill>
+            <a:srgbClr val="0B2C4A"/>
           </a:solidFill>
           <a:ln>
             <a:noFill/>
@@ -16665,8 +16049,8 @@
         </p:nvSpPr>
         <p:spPr>
           <a:xfrm>
-            <a:off x="667512" y="1207008"/>
-            <a:ext cx="5257800" cy="329184"/>
+            <a:off x="365760" y="1051560"/>
+            <a:ext cx="5212080" cy="365760"/>
           </a:xfrm>
           <a:prstGeom prst="rect">
             <a:avLst/>
@@ -16674,58 +16058,46 @@
           <a:noFill/>
         </p:spPr>
         <p:txBody>
-          <a:bodyPr wrap="square" anchor="t"/>
-          <a:lstStyle/>
-          <a:p>
-            <a:pPr algn="l"/>
-            <a:r>
-              <a:rPr sz="1800" b="1">
-                <a:solidFill>
-                  <a:srgbClr val="0B2C4A"/>
-                </a:solidFill>
-                <a:latin typeface="Calibri"/>
-              </a:rPr>
-              <a:t>Construction</a:t>
-            </a:r>
-          </a:p>
-        </p:txBody>
-      </p:sp>
-      <p:sp>
-        <p:nvSpPr>
-          <p:cNvPr id="10" name="TextBox 9"/>
-          <p:cNvSpPr txBox="1"/>
-          <p:nvPr/>
-        </p:nvSpPr>
-        <p:spPr>
-          <a:xfrm>
-            <a:off x="667512" y="1554480"/>
-            <a:ext cx="5257800" cy="4553712"/>
-          </a:xfrm>
-          <a:prstGeom prst="rect">
-            <a:avLst/>
-          </a:prstGeom>
-          <a:noFill/>
-        </p:spPr>
-        <p:txBody>
-          <a:bodyPr wrap="square" anchor="t"/>
-          <a:lstStyle/>
-          <a:p>
-            <a:pPr algn="l"/>
-            <a:r>
-              <a:rPr sz="1600" b="0">
-                <a:solidFill>
-                  <a:srgbClr val="3D4A57"/>
-                </a:solidFill>
-                <a:latin typeface="Calibri"/>
-              </a:rPr>
-              <a:t>Interrupted. Appositional to everting, depending on how hard you pull (WCVM).
-The second bite is parallel to the first. Tension sits lateral to the wound (Merck Professional mattress pages).
-Major blood-supply cost if overtightened.
-Useful when you need to spread load. Dangerous on thin or already ischemic skin.</a:t>
-            </a:r>
-          </a:p>
-        </p:txBody>
-      </p:sp>
+          <a:bodyPr wrap="square" anchor="ctr"/>
+          <a:lstStyle/>
+          <a:p>
+            <a:pPr algn="ctr"/>
+            <a:r>
+              <a:rPr sz="1400" b="1">
+                <a:solidFill>
+                  <a:srgbClr val="C5A35A"/>
+                </a:solidFill>
+                <a:latin typeface="Calibri"/>
+              </a:rPr>
+              <a:t>Original 3D teaching figure</a:t>
+            </a:r>
+          </a:p>
+        </p:txBody>
+      </p:sp>
+      <p:pic>
+        <p:nvPicPr>
+          <p:cNvPr id="10" name="Picture 9" descr="suture3d_horizontal_mattress.png"/>
+          <p:cNvPicPr>
+            <a:picLocks noChangeAspect="1"/>
+          </p:cNvPicPr>
+          <p:nvPr/>
+        </p:nvPicPr>
+        <p:blipFill>
+          <a:blip r:embed="rId2"/>
+          <a:stretch>
+            <a:fillRect/>
+          </a:stretch>
+        </p:blipFill>
+        <p:spPr>
+          <a:xfrm>
+            <a:off x="493776" y="1940814"/>
+            <a:ext cx="4956048" cy="3717036"/>
+          </a:xfrm>
+          <a:prstGeom prst="rect">
+            <a:avLst/>
+          </a:prstGeom>
+        </p:spPr>
+      </p:pic>
       <p:sp>
         <p:nvSpPr>
           <p:cNvPr id="11" name="Rounded Rectangle 10"/>
@@ -16734,8 +16106,8 @@
         </p:nvSpPr>
         <p:spPr>
           <a:xfrm>
-            <a:off x="6217920" y="1097280"/>
-            <a:ext cx="5532120" cy="5120640"/>
+            <a:off x="5760720" y="1051560"/>
+            <a:ext cx="5989320" cy="2468880"/>
           </a:xfrm>
           <a:prstGeom prst="roundRect">
             <a:avLst>
@@ -16779,14 +16151,14 @@
         </p:nvSpPr>
         <p:spPr>
           <a:xfrm>
-            <a:off x="6217920" y="1097280"/>
-            <a:ext cx="91440" cy="5120640"/>
-          </a:xfrm>
-          <a:prstGeom prst="rect">
-            <a:avLst/>
-          </a:prstGeom>
-          <a:solidFill>
-            <a:srgbClr val="8B2E2E"/>
+            <a:off x="5760720" y="1051560"/>
+            <a:ext cx="91440" cy="2468880"/>
+          </a:xfrm>
+          <a:prstGeom prst="rect">
+            <a:avLst/>
+          </a:prstGeom>
+          <a:solidFill>
+            <a:srgbClr val="C5A35A"/>
           </a:solidFill>
           <a:ln>
             <a:noFill/>
@@ -16822,8 +16194,8 @@
         </p:nvSpPr>
         <p:spPr>
           <a:xfrm>
-            <a:off x="6473952" y="1207008"/>
-            <a:ext cx="5166360" cy="329184"/>
+            <a:off x="6016752" y="1161288"/>
+            <a:ext cx="5623560" cy="329184"/>
           </a:xfrm>
           <a:prstGeom prst="rect">
             <a:avLst/>
@@ -16842,7 +16214,7 @@
                 </a:solidFill>
                 <a:latin typeface="Calibri"/>
               </a:rPr>
-              <a:t>Do not</a:t>
+              <a:t>Construction</a:t>
             </a:r>
           </a:p>
         </p:txBody>
@@ -16855,8 +16227,164 @@
         </p:nvSpPr>
         <p:spPr>
           <a:xfrm>
-            <a:off x="6473952" y="1554480"/>
-            <a:ext cx="5166360" cy="4553712"/>
+            <a:off x="6016752" y="1508760"/>
+            <a:ext cx="5623560" cy="1901952"/>
+          </a:xfrm>
+          <a:prstGeom prst="rect">
+            <a:avLst/>
+          </a:prstGeom>
+          <a:noFill/>
+        </p:spPr>
+        <p:txBody>
+          <a:bodyPr wrap="square" anchor="t"/>
+          <a:lstStyle/>
+          <a:p>
+            <a:pPr algn="l"/>
+            <a:r>
+              <a:rPr sz="1600" b="0">
+                <a:solidFill>
+                  <a:srgbClr val="3D4A57"/>
+                </a:solidFill>
+                <a:latin typeface="Calibri"/>
+              </a:rPr>
+              <a:t>Interrupted. Appositional to everting, depending on how hard you pull (WCVM).
+The second bite is parallel to the first. Tension sits lateral to the wound (Merck).
+Major blood-supply cost if overtightened.</a:t>
+            </a:r>
+          </a:p>
+        </p:txBody>
+      </p:sp>
+      <p:sp>
+        <p:nvSpPr>
+          <p:cNvPr id="15" name="Rounded Rectangle 14"/>
+          <p:cNvSpPr/>
+          <p:nvPr/>
+        </p:nvSpPr>
+        <p:spPr>
+          <a:xfrm>
+            <a:off x="5760720" y="3703320"/>
+            <a:ext cx="5989320" cy="2514600"/>
+          </a:xfrm>
+          <a:prstGeom prst="roundRect">
+            <a:avLst>
+              <a:gd name="adj" fmla="val 8000"/>
+            </a:avLst>
+          </a:prstGeom>
+          <a:solidFill>
+            <a:srgbClr val="FFFFFF"/>
+          </a:solidFill>
+          <a:ln>
+            <a:noFill/>
+          </a:ln>
+        </p:spPr>
+        <p:style>
+          <a:lnRef idx="1">
+            <a:schemeClr val="accent1"/>
+          </a:lnRef>
+          <a:fillRef idx="3">
+            <a:schemeClr val="accent1"/>
+          </a:fillRef>
+          <a:effectRef idx="2">
+            <a:schemeClr val="accent1"/>
+          </a:effectRef>
+          <a:fontRef idx="minor">
+            <a:schemeClr val="lt1"/>
+          </a:fontRef>
+        </p:style>
+        <p:txBody>
+          <a:bodyPr rtlCol="0" anchor="ctr"/>
+          <a:lstStyle/>
+          <a:p>
+            <a:pPr algn="ctr"/>
+          </a:p>
+        </p:txBody>
+      </p:sp>
+      <p:sp>
+        <p:nvSpPr>
+          <p:cNvPr id="16" name="Rectangle 15"/>
+          <p:cNvSpPr/>
+          <p:nvPr/>
+        </p:nvSpPr>
+        <p:spPr>
+          <a:xfrm>
+            <a:off x="5760720" y="3703320"/>
+            <a:ext cx="91440" cy="2514600"/>
+          </a:xfrm>
+          <a:prstGeom prst="rect">
+            <a:avLst/>
+          </a:prstGeom>
+          <a:solidFill>
+            <a:srgbClr val="8B2E2E"/>
+          </a:solidFill>
+          <a:ln>
+            <a:noFill/>
+          </a:ln>
+        </p:spPr>
+        <p:style>
+          <a:lnRef idx="1">
+            <a:schemeClr val="accent1"/>
+          </a:lnRef>
+          <a:fillRef idx="3">
+            <a:schemeClr val="accent1"/>
+          </a:fillRef>
+          <a:effectRef idx="2">
+            <a:schemeClr val="accent1"/>
+          </a:effectRef>
+          <a:fontRef idx="minor">
+            <a:schemeClr val="lt1"/>
+          </a:fontRef>
+        </p:style>
+        <p:txBody>
+          <a:bodyPr rtlCol="0" anchor="ctr"/>
+          <a:lstStyle/>
+          <a:p>
+            <a:pPr algn="ctr"/>
+          </a:p>
+        </p:txBody>
+      </p:sp>
+      <p:sp>
+        <p:nvSpPr>
+          <p:cNvPr id="17" name="TextBox 16"/>
+          <p:cNvSpPr txBox="1"/>
+          <p:nvPr/>
+        </p:nvSpPr>
+        <p:spPr>
+          <a:xfrm>
+            <a:off x="6016752" y="3813048"/>
+            <a:ext cx="5623560" cy="329184"/>
+          </a:xfrm>
+          <a:prstGeom prst="rect">
+            <a:avLst/>
+          </a:prstGeom>
+          <a:noFill/>
+        </p:spPr>
+        <p:txBody>
+          <a:bodyPr wrap="square" anchor="t"/>
+          <a:lstStyle/>
+          <a:p>
+            <a:pPr algn="l"/>
+            <a:r>
+              <a:rPr sz="1800" b="1">
+                <a:solidFill>
+                  <a:srgbClr val="0B2C4A"/>
+                </a:solidFill>
+                <a:latin typeface="Calibri"/>
+              </a:rPr>
+              <a:t>Do not</a:t>
+            </a:r>
+          </a:p>
+        </p:txBody>
+      </p:sp>
+      <p:sp>
+        <p:nvSpPr>
+          <p:cNvPr id="18" name="TextBox 17"/>
+          <p:cNvSpPr txBox="1"/>
+          <p:nvPr/>
+        </p:nvSpPr>
+        <p:spPr>
+          <a:xfrm>
+            <a:off x="6016752" y="4160520"/>
+            <a:ext cx="5623560" cy="1947672"/>
           </a:xfrm>
           <a:prstGeom prst="rect">
             <a:avLst/>
@@ -16877,15 +16405,14 @@
               </a:rPr>
               <a:t>Do not use it to hide a closure that needed undermining.
 Do not bury the edge until it blanches.
-Stents or bolsters are a hospital conversation, not a homemade table.
-Confirm bite geometry in Fossum or the lab.</a:t>
-            </a:r>
-          </a:p>
-        </p:txBody>
-      </p:sp>
-      <p:sp>
-        <p:nvSpPr>
-          <p:cNvPr id="15" name="Rectangle 14"/>
+Confirm bite geometry in Fossum or the lab. Do not invent millimeters.</a:t>
+            </a:r>
+          </a:p>
+        </p:txBody>
+      </p:sp>
+      <p:sp>
+        <p:nvSpPr>
+          <p:cNvPr id="19" name="Rectangle 18"/>
           <p:cNvSpPr/>
           <p:nvPr/>
         </p:nvSpPr>
@@ -16928,7 +16455,7 @@
       </p:sp>
       <p:sp>
         <p:nvSpPr>
-          <p:cNvPr id="16" name="TextBox 15"/>
+          <p:cNvPr id="20" name="TextBox 19"/>
           <p:cNvSpPr txBox="1"/>
           <p:nvPr/>
         </p:nvSpPr>
@@ -16961,7 +16488,7 @@
       </p:sp>
       <p:sp>
         <p:nvSpPr>
-          <p:cNvPr id="17" name="TextBox 16"/>
+          <p:cNvPr id="21" name="TextBox 20"/>
           <p:cNvSpPr txBox="1"/>
           <p:nvPr/>
         </p:nvSpPr>
@@ -17223,8 +16750,8 @@
         </p:nvSpPr>
         <p:spPr>
           <a:xfrm>
-            <a:off x="411480" y="1097280"/>
-            <a:ext cx="5623560" cy="5120640"/>
+            <a:off x="365760" y="1051560"/>
+            <a:ext cx="5212080" cy="5166360"/>
           </a:xfrm>
           <a:prstGeom prst="roundRect">
             <a:avLst>
@@ -17268,14 +16795,14 @@
         </p:nvSpPr>
         <p:spPr>
           <a:xfrm>
-            <a:off x="411480" y="1097280"/>
-            <a:ext cx="91440" cy="5120640"/>
-          </a:xfrm>
-          <a:prstGeom prst="rect">
-            <a:avLst/>
-          </a:prstGeom>
-          <a:solidFill>
-            <a:srgbClr val="C5A35A"/>
+            <a:off x="365760" y="1051560"/>
+            <a:ext cx="5212080" cy="365760"/>
+          </a:xfrm>
+          <a:prstGeom prst="rect">
+            <a:avLst/>
+          </a:prstGeom>
+          <a:solidFill>
+            <a:srgbClr val="0B2C4A"/>
           </a:solidFill>
           <a:ln>
             <a:noFill/>
@@ -17311,8 +16838,8 @@
         </p:nvSpPr>
         <p:spPr>
           <a:xfrm>
-            <a:off x="667512" y="1207008"/>
-            <a:ext cx="5257800" cy="329184"/>
+            <a:off x="365760" y="1051560"/>
+            <a:ext cx="5212080" cy="365760"/>
           </a:xfrm>
           <a:prstGeom prst="rect">
             <a:avLst/>
@@ -17320,58 +16847,46 @@
           <a:noFill/>
         </p:spPr>
         <p:txBody>
-          <a:bodyPr wrap="square" anchor="t"/>
-          <a:lstStyle/>
-          <a:p>
-            <a:pPr algn="l"/>
-            <a:r>
-              <a:rPr sz="1800" b="1">
-                <a:solidFill>
-                  <a:srgbClr val="0B2C4A"/>
-                </a:solidFill>
-                <a:latin typeface="Calibri"/>
-              </a:rPr>
-              <a:t>Far-far, then near-near</a:t>
-            </a:r>
-          </a:p>
-        </p:txBody>
-      </p:sp>
-      <p:sp>
-        <p:nvSpPr>
-          <p:cNvPr id="10" name="TextBox 9"/>
-          <p:cNvSpPr txBox="1"/>
-          <p:nvPr/>
-        </p:nvSpPr>
-        <p:spPr>
-          <a:xfrm>
-            <a:off x="667512" y="1554480"/>
-            <a:ext cx="5257800" cy="4553712"/>
-          </a:xfrm>
-          <a:prstGeom prst="rect">
-            <a:avLst/>
-          </a:prstGeom>
-          <a:noFill/>
-        </p:spPr>
-        <p:txBody>
-          <a:bodyPr wrap="square" anchor="t"/>
-          <a:lstStyle/>
-          <a:p>
-            <a:pPr algn="l"/>
-            <a:r>
-              <a:rPr sz="1600" b="0">
-                <a:solidFill>
-                  <a:srgbClr val="3D4A57"/>
-                </a:solidFill>
-                <a:latin typeface="Calibri"/>
-              </a:rPr>
-              <a:t>Interrupted. Everting. A tension suture (WCVM).
-Merck Professional: one wide-deep loop, then one narrow-shallow loop. Far-far, then near-near.
-Aligns deep and superficial tissue in one stitch.
-Less blood-supply cost than a horizontal mattress, more than a simple interrupted.</a:t>
-            </a:r>
-          </a:p>
-        </p:txBody>
-      </p:sp>
+          <a:bodyPr wrap="square" anchor="ctr"/>
+          <a:lstStyle/>
+          <a:p>
+            <a:pPr algn="ctr"/>
+            <a:r>
+              <a:rPr sz="1400" b="1">
+                <a:solidFill>
+                  <a:srgbClr val="C5A35A"/>
+                </a:solidFill>
+                <a:latin typeface="Calibri"/>
+              </a:rPr>
+              <a:t>Original 3D teaching figure</a:t>
+            </a:r>
+          </a:p>
+        </p:txBody>
+      </p:sp>
+      <p:pic>
+        <p:nvPicPr>
+          <p:cNvPr id="10" name="Picture 9" descr="suture3d_vertical_mattress.png"/>
+          <p:cNvPicPr>
+            <a:picLocks noChangeAspect="1"/>
+          </p:cNvPicPr>
+          <p:nvPr/>
+        </p:nvPicPr>
+        <p:blipFill>
+          <a:blip r:embed="rId2"/>
+          <a:stretch>
+            <a:fillRect/>
+          </a:stretch>
+        </p:blipFill>
+        <p:spPr>
+          <a:xfrm>
+            <a:off x="493776" y="1940814"/>
+            <a:ext cx="4956048" cy="3717036"/>
+          </a:xfrm>
+          <a:prstGeom prst="rect">
+            <a:avLst/>
+          </a:prstGeom>
+        </p:spPr>
+      </p:pic>
       <p:sp>
         <p:nvSpPr>
           <p:cNvPr id="11" name="Rounded Rectangle 10"/>
@@ -17380,8 +16895,8 @@
         </p:nvSpPr>
         <p:spPr>
           <a:xfrm>
-            <a:off x="6217920" y="1097280"/>
-            <a:ext cx="5532120" cy="5120640"/>
+            <a:off x="5760720" y="1051560"/>
+            <a:ext cx="5989320" cy="2468880"/>
           </a:xfrm>
           <a:prstGeom prst="roundRect">
             <a:avLst>
@@ -17425,14 +16940,14 @@
         </p:nvSpPr>
         <p:spPr>
           <a:xfrm>
-            <a:off x="6217920" y="1097280"/>
-            <a:ext cx="91440" cy="5120640"/>
-          </a:xfrm>
-          <a:prstGeom prst="rect">
-            <a:avLst/>
-          </a:prstGeom>
-          <a:solidFill>
-            <a:srgbClr val="8B2E2E"/>
+            <a:off x="5760720" y="1051560"/>
+            <a:ext cx="91440" cy="2468880"/>
+          </a:xfrm>
+          <a:prstGeom prst="rect">
+            <a:avLst/>
+          </a:prstGeom>
+          <a:solidFill>
+            <a:srgbClr val="C5A35A"/>
           </a:solidFill>
           <a:ln>
             <a:noFill/>
@@ -17468,8 +16983,8 @@
         </p:nvSpPr>
         <p:spPr>
           <a:xfrm>
-            <a:off x="6473952" y="1207008"/>
-            <a:ext cx="5166360" cy="329184"/>
+            <a:off x="6016752" y="1161288"/>
+            <a:ext cx="5623560" cy="329184"/>
           </a:xfrm>
           <a:prstGeom prst="rect">
             <a:avLst/>
@@ -17488,7 +17003,7 @@
                 </a:solidFill>
                 <a:latin typeface="Calibri"/>
               </a:rPr>
-              <a:t>Do not</a:t>
+              <a:t>Far-far, then near-near</a:t>
             </a:r>
           </a:p>
         </p:txBody>
@@ -17501,8 +17016,164 @@
         </p:nvSpPr>
         <p:spPr>
           <a:xfrm>
-            <a:off x="6473952" y="1554480"/>
-            <a:ext cx="5166360" cy="4553712"/>
+            <a:off x="6016752" y="1508760"/>
+            <a:ext cx="5623560" cy="1901952"/>
+          </a:xfrm>
+          <a:prstGeom prst="rect">
+            <a:avLst/>
+          </a:prstGeom>
+          <a:noFill/>
+        </p:spPr>
+        <p:txBody>
+          <a:bodyPr wrap="square" anchor="t"/>
+          <a:lstStyle/>
+          <a:p>
+            <a:pPr algn="l"/>
+            <a:r>
+              <a:rPr sz="1600" b="0">
+                <a:solidFill>
+                  <a:srgbClr val="3D4A57"/>
+                </a:solidFill>
+                <a:latin typeface="Calibri"/>
+              </a:rPr>
+              <a:t>Interrupted. Everting. A tension suture (WCVM).
+Merck Professional: one wide-deep loop, then one narrow-shallow loop. Far-far, then near-near.
+Aligns deep and superficial tissue in one stitch.</a:t>
+            </a:r>
+          </a:p>
+        </p:txBody>
+      </p:sp>
+      <p:sp>
+        <p:nvSpPr>
+          <p:cNvPr id="15" name="Rounded Rectangle 14"/>
+          <p:cNvSpPr/>
+          <p:nvPr/>
+        </p:nvSpPr>
+        <p:spPr>
+          <a:xfrm>
+            <a:off x="5760720" y="3703320"/>
+            <a:ext cx="5989320" cy="2514600"/>
+          </a:xfrm>
+          <a:prstGeom prst="roundRect">
+            <a:avLst>
+              <a:gd name="adj" fmla="val 8000"/>
+            </a:avLst>
+          </a:prstGeom>
+          <a:solidFill>
+            <a:srgbClr val="FFFFFF"/>
+          </a:solidFill>
+          <a:ln>
+            <a:noFill/>
+          </a:ln>
+        </p:spPr>
+        <p:style>
+          <a:lnRef idx="1">
+            <a:schemeClr val="accent1"/>
+          </a:lnRef>
+          <a:fillRef idx="3">
+            <a:schemeClr val="accent1"/>
+          </a:fillRef>
+          <a:effectRef idx="2">
+            <a:schemeClr val="accent1"/>
+          </a:effectRef>
+          <a:fontRef idx="minor">
+            <a:schemeClr val="lt1"/>
+          </a:fontRef>
+        </p:style>
+        <p:txBody>
+          <a:bodyPr rtlCol="0" anchor="ctr"/>
+          <a:lstStyle/>
+          <a:p>
+            <a:pPr algn="ctr"/>
+          </a:p>
+        </p:txBody>
+      </p:sp>
+      <p:sp>
+        <p:nvSpPr>
+          <p:cNvPr id="16" name="Rectangle 15"/>
+          <p:cNvSpPr/>
+          <p:nvPr/>
+        </p:nvSpPr>
+        <p:spPr>
+          <a:xfrm>
+            <a:off x="5760720" y="3703320"/>
+            <a:ext cx="91440" cy="2514600"/>
+          </a:xfrm>
+          <a:prstGeom prst="rect">
+            <a:avLst/>
+          </a:prstGeom>
+          <a:solidFill>
+            <a:srgbClr val="8B2E2E"/>
+          </a:solidFill>
+          <a:ln>
+            <a:noFill/>
+          </a:ln>
+        </p:spPr>
+        <p:style>
+          <a:lnRef idx="1">
+            <a:schemeClr val="accent1"/>
+          </a:lnRef>
+          <a:fillRef idx="3">
+            <a:schemeClr val="accent1"/>
+          </a:fillRef>
+          <a:effectRef idx="2">
+            <a:schemeClr val="accent1"/>
+          </a:effectRef>
+          <a:fontRef idx="minor">
+            <a:schemeClr val="lt1"/>
+          </a:fontRef>
+        </p:style>
+        <p:txBody>
+          <a:bodyPr rtlCol="0" anchor="ctr"/>
+          <a:lstStyle/>
+          <a:p>
+            <a:pPr algn="ctr"/>
+          </a:p>
+        </p:txBody>
+      </p:sp>
+      <p:sp>
+        <p:nvSpPr>
+          <p:cNvPr id="17" name="TextBox 16"/>
+          <p:cNvSpPr txBox="1"/>
+          <p:nvPr/>
+        </p:nvSpPr>
+        <p:spPr>
+          <a:xfrm>
+            <a:off x="6016752" y="3813048"/>
+            <a:ext cx="5623560" cy="329184"/>
+          </a:xfrm>
+          <a:prstGeom prst="rect">
+            <a:avLst/>
+          </a:prstGeom>
+          <a:noFill/>
+        </p:spPr>
+        <p:txBody>
+          <a:bodyPr wrap="square" anchor="t"/>
+          <a:lstStyle/>
+          <a:p>
+            <a:pPr algn="l"/>
+            <a:r>
+              <a:rPr sz="1800" b="1">
+                <a:solidFill>
+                  <a:srgbClr val="0B2C4A"/>
+                </a:solidFill>
+                <a:latin typeface="Calibri"/>
+              </a:rPr>
+              <a:t>Do not</a:t>
+            </a:r>
+          </a:p>
+        </p:txBody>
+      </p:sp>
+      <p:sp>
+        <p:nvSpPr>
+          <p:cNvPr id="18" name="TextBox 17"/>
+          <p:cNvSpPr txBox="1"/>
+          <p:nvPr/>
+        </p:nvSpPr>
+        <p:spPr>
+          <a:xfrm>
+            <a:off x="6016752" y="4160520"/>
+            <a:ext cx="5623560" cy="1947672"/>
           </a:xfrm>
           <a:prstGeom prst="rect">
             <a:avLst/>
@@ -17523,7 +17194,6 @@
               </a:rPr>
               <a:t>Do not place the near-near first. The shallow loop can cut the skin.
 Do not treat eversion as a cosmetic win on dog or cat skin.
-Cross-hatching and ischemia are the published costs (Merck).
 Confirm distances in Fossum or the lab. Do not invent millimeters.</a:t>
             </a:r>
           </a:p>
@@ -17531,7 +17201,7 @@
       </p:sp>
       <p:sp>
         <p:nvSpPr>
-          <p:cNvPr id="15" name="Rectangle 14"/>
+          <p:cNvPr id="19" name="Rectangle 18"/>
           <p:cNvSpPr/>
           <p:nvPr/>
         </p:nvSpPr>
@@ -17574,7 +17244,7 @@
       </p:sp>
       <p:sp>
         <p:nvSpPr>
-          <p:cNvPr id="16" name="TextBox 15"/>
+          <p:cNvPr id="20" name="TextBox 19"/>
           <p:cNvSpPr txBox="1"/>
           <p:nvPr/>
         </p:nvSpPr>
@@ -17607,7 +17277,7 @@
       </p:sp>
       <p:sp>
         <p:nvSpPr>
-          <p:cNvPr id="17" name="TextBox 16"/>
+          <p:cNvPr id="21" name="TextBox 20"/>
           <p:cNvSpPr txBox="1"/>
           <p:nvPr/>
         </p:nvSpPr>
@@ -17863,14 +17533,102 @@
       </p:sp>
       <p:sp>
         <p:nvSpPr>
-          <p:cNvPr id="7" name="TextBox 6"/>
+          <p:cNvPr id="7" name="Rounded Rectangle 6"/>
+          <p:cNvSpPr/>
+          <p:nvPr/>
+        </p:nvSpPr>
+        <p:spPr>
+          <a:xfrm>
+            <a:off x="365760" y="1051560"/>
+            <a:ext cx="5212080" cy="5166360"/>
+          </a:xfrm>
+          <a:prstGeom prst="roundRect">
+            <a:avLst>
+              <a:gd name="adj" fmla="val 8000"/>
+            </a:avLst>
+          </a:prstGeom>
+          <a:solidFill>
+            <a:srgbClr val="FFFFFF"/>
+          </a:solidFill>
+          <a:ln>
+            <a:noFill/>
+          </a:ln>
+        </p:spPr>
+        <p:style>
+          <a:lnRef idx="1">
+            <a:schemeClr val="accent1"/>
+          </a:lnRef>
+          <a:fillRef idx="3">
+            <a:schemeClr val="accent1"/>
+          </a:fillRef>
+          <a:effectRef idx="2">
+            <a:schemeClr val="accent1"/>
+          </a:effectRef>
+          <a:fontRef idx="minor">
+            <a:schemeClr val="lt1"/>
+          </a:fontRef>
+        </p:style>
+        <p:txBody>
+          <a:bodyPr rtlCol="0" anchor="ctr"/>
+          <a:lstStyle/>
+          <a:p>
+            <a:pPr algn="ctr"/>
+          </a:p>
+        </p:txBody>
+      </p:sp>
+      <p:sp>
+        <p:nvSpPr>
+          <p:cNvPr id="8" name="Rectangle 7"/>
+          <p:cNvSpPr/>
+          <p:nvPr/>
+        </p:nvSpPr>
+        <p:spPr>
+          <a:xfrm>
+            <a:off x="365760" y="1051560"/>
+            <a:ext cx="5212080" cy="365760"/>
+          </a:xfrm>
+          <a:prstGeom prst="rect">
+            <a:avLst/>
+          </a:prstGeom>
+          <a:solidFill>
+            <a:srgbClr val="0B2C4A"/>
+          </a:solidFill>
+          <a:ln>
+            <a:noFill/>
+          </a:ln>
+        </p:spPr>
+        <p:style>
+          <a:lnRef idx="1">
+            <a:schemeClr val="accent1"/>
+          </a:lnRef>
+          <a:fillRef idx="3">
+            <a:schemeClr val="accent1"/>
+          </a:fillRef>
+          <a:effectRef idx="2">
+            <a:schemeClr val="accent1"/>
+          </a:effectRef>
+          <a:fontRef idx="minor">
+            <a:schemeClr val="lt1"/>
+          </a:fontRef>
+        </p:style>
+        <p:txBody>
+          <a:bodyPr rtlCol="0" anchor="ctr"/>
+          <a:lstStyle/>
+          <a:p>
+            <a:pPr algn="ctr"/>
+          </a:p>
+        </p:txBody>
+      </p:sp>
+      <p:sp>
+        <p:nvSpPr>
+          <p:cNvPr id="9" name="TextBox 8"/>
           <p:cNvSpPr txBox="1"/>
           <p:nvPr/>
         </p:nvSpPr>
         <p:spPr>
           <a:xfrm>
-            <a:off x="502920" y="1143000"/>
-            <a:ext cx="11155680" cy="4937760"/>
+            <a:off x="365760" y="1051560"/>
+            <a:ext cx="5212080" cy="365760"/>
           </a:xfrm>
           <a:prstGeom prst="rect">
             <a:avLst/>
@@ -17878,95 +17636,207 @@
           <a:noFill/>
         </p:spPr>
         <p:txBody>
-          <a:bodyPr wrap="square">
-            <a:spAutoFit/>
-          </a:bodyPr>
-          <a:lstStyle/>
-          <a:p>
-            <a:pPr algn="l">
-              <a:spcAft>
-                <a:spcPts val="1200"/>
-              </a:spcAft>
-            </a:pPr>
-            <a:r>
-              <a:rPr sz="2000">
-                <a:solidFill>
-                  <a:srgbClr val="1C1C1C"/>
-                </a:solidFill>
-                <a:latin typeface="Calibri"/>
-              </a:rPr>
-              <a:t>▸  Interrupted. Appositional. A tension suture (WCVM).</a:t>
-            </a:r>
-          </a:p>
-          <a:p>
-            <a:pPr algn="l">
-              <a:spcAft>
-                <a:spcPts val="1200"/>
-              </a:spcAft>
-            </a:pPr>
-            <a:r>
-              <a:rPr sz="2000">
-                <a:solidFill>
-                  <a:srgbClr val="1C1C1C"/>
-                </a:solidFill>
-                <a:latin typeface="Calibri"/>
-              </a:rPr>
-              <a:t>▸  The far bite takes the load. The near bite apposes the edge.</a:t>
-            </a:r>
-          </a:p>
-          <a:p>
-            <a:pPr algn="l">
-              <a:spcAft>
-                <a:spcPts val="1200"/>
-              </a:spcAft>
-            </a:pPr>
-            <a:r>
-              <a:rPr sz="2000">
-                <a:solidFill>
-                  <a:srgbClr val="1C1C1C"/>
-                </a:solidFill>
-                <a:latin typeface="Calibri"/>
-              </a:rPr>
-              <a:t>▸  The name is the order of the bites: near-far-far-near, or far-near-near-far.</a:t>
-            </a:r>
-          </a:p>
-          <a:p>
-            <a:pPr algn="l">
-              <a:spcAft>
-                <a:spcPts val="1200"/>
-              </a:spcAft>
-            </a:pPr>
-            <a:r>
-              <a:rPr sz="2000">
-                <a:solidFill>
-                  <a:srgbClr val="1C1C1C"/>
-                </a:solidFill>
-                <a:latin typeface="Calibri"/>
-              </a:rPr>
-              <a:t>▸  Less blood-supply cost than a horizontal mattress, more than a simple interrupted.</a:t>
-            </a:r>
-          </a:p>
-          <a:p>
-            <a:pPr algn="l">
-              <a:spcAft>
-                <a:spcPts val="1200"/>
-              </a:spcAft>
-            </a:pPr>
-            <a:r>
-              <a:rPr sz="2000">
-                <a:solidFill>
-                  <a:srgbClr val="1C1C1C"/>
-                </a:solidFill>
-                <a:latin typeface="Calibri"/>
-              </a:rPr>
-              <a:t>▸  Use when you need both tension relief and edge-to-edge skin. Still fix the real tension first.</a:t>
-            </a:r>
-          </a:p>
-        </p:txBody>
-      </p:sp>
-      <p:sp>
-        <p:nvSpPr>
-          <p:cNvPr id="8" name="Rectangle 7"/>
+          <a:bodyPr wrap="square" anchor="ctr"/>
+          <a:lstStyle/>
+          <a:p>
+            <a:pPr algn="ctr"/>
+            <a:r>
+              <a:rPr sz="1400" b="1">
+                <a:solidFill>
+                  <a:srgbClr val="C5A35A"/>
+                </a:solidFill>
+                <a:latin typeface="Calibri"/>
+              </a:rPr>
+              <a:t>Original 3D teaching figure</a:t>
+            </a:r>
+          </a:p>
+        </p:txBody>
+      </p:sp>
+      <p:pic>
+        <p:nvPicPr>
+          <p:cNvPr id="10" name="Picture 9" descr="suture3d_near_far.png"/>
+          <p:cNvPicPr>
+            <a:picLocks noChangeAspect="1"/>
+          </p:cNvPicPr>
+          <p:nvPr/>
+        </p:nvPicPr>
+        <p:blipFill>
+          <a:blip r:embed="rId2"/>
+          <a:stretch>
+            <a:fillRect/>
+          </a:stretch>
+        </p:blipFill>
+        <p:spPr>
+          <a:xfrm>
+            <a:off x="493776" y="1940814"/>
+            <a:ext cx="4956048" cy="3717036"/>
+          </a:xfrm>
+          <a:prstGeom prst="rect">
+            <a:avLst/>
+          </a:prstGeom>
+        </p:spPr>
+      </p:pic>
+      <p:sp>
+        <p:nvSpPr>
+          <p:cNvPr id="11" name="Rounded Rectangle 10"/>
+          <p:cNvSpPr/>
+          <p:nvPr/>
+        </p:nvSpPr>
+        <p:spPr>
+          <a:xfrm>
+            <a:off x="5760720" y="1051560"/>
+            <a:ext cx="5989320" cy="5166360"/>
+          </a:xfrm>
+          <a:prstGeom prst="roundRect">
+            <a:avLst>
+              <a:gd name="adj" fmla="val 8000"/>
+            </a:avLst>
+          </a:prstGeom>
+          <a:solidFill>
+            <a:srgbClr val="FFFFFF"/>
+          </a:solidFill>
+          <a:ln>
+            <a:noFill/>
+          </a:ln>
+        </p:spPr>
+        <p:style>
+          <a:lnRef idx="1">
+            <a:schemeClr val="accent1"/>
+          </a:lnRef>
+          <a:fillRef idx="3">
+            <a:schemeClr val="accent1"/>
+          </a:fillRef>
+          <a:effectRef idx="2">
+            <a:schemeClr val="accent1"/>
+          </a:effectRef>
+          <a:fontRef idx="minor">
+            <a:schemeClr val="lt1"/>
+          </a:fontRef>
+        </p:style>
+        <p:txBody>
+          <a:bodyPr rtlCol="0" anchor="ctr"/>
+          <a:lstStyle/>
+          <a:p>
+            <a:pPr algn="ctr"/>
+          </a:p>
+        </p:txBody>
+      </p:sp>
+      <p:sp>
+        <p:nvSpPr>
+          <p:cNvPr id="12" name="Rectangle 11"/>
+          <p:cNvSpPr/>
+          <p:nvPr/>
+        </p:nvSpPr>
+        <p:spPr>
+          <a:xfrm>
+            <a:off x="5760720" y="1051560"/>
+            <a:ext cx="91440" cy="5166360"/>
+          </a:xfrm>
+          <a:prstGeom prst="rect">
+            <a:avLst/>
+          </a:prstGeom>
+          <a:solidFill>
+            <a:srgbClr val="C5A35A"/>
+          </a:solidFill>
+          <a:ln>
+            <a:noFill/>
+          </a:ln>
+        </p:spPr>
+        <p:style>
+          <a:lnRef idx="1">
+            <a:schemeClr val="accent1"/>
+          </a:lnRef>
+          <a:fillRef idx="3">
+            <a:schemeClr val="accent1"/>
+          </a:fillRef>
+          <a:effectRef idx="2">
+            <a:schemeClr val="accent1"/>
+          </a:effectRef>
+          <a:fontRef idx="minor">
+            <a:schemeClr val="lt1"/>
+          </a:fontRef>
+        </p:style>
+        <p:txBody>
+          <a:bodyPr rtlCol="0" anchor="ctr"/>
+          <a:lstStyle/>
+          <a:p>
+            <a:pPr algn="ctr"/>
+          </a:p>
+        </p:txBody>
+      </p:sp>
+      <p:sp>
+        <p:nvSpPr>
+          <p:cNvPr id="13" name="TextBox 12"/>
+          <p:cNvSpPr txBox="1"/>
+          <p:nvPr/>
+        </p:nvSpPr>
+        <p:spPr>
+          <a:xfrm>
+            <a:off x="6016752" y="1161288"/>
+            <a:ext cx="5623560" cy="329184"/>
+          </a:xfrm>
+          <a:prstGeom prst="rect">
+            <a:avLst/>
+          </a:prstGeom>
+          <a:noFill/>
+        </p:spPr>
+        <p:txBody>
+          <a:bodyPr wrap="square" anchor="t"/>
+          <a:lstStyle/>
+          <a:p>
+            <a:pPr algn="l"/>
+            <a:r>
+              <a:rPr sz="1800" b="1">
+                <a:solidFill>
+                  <a:srgbClr val="0B2C4A"/>
+                </a:solidFill>
+                <a:latin typeface="Calibri"/>
+              </a:rPr>
+              <a:t>What to say</a:t>
+            </a:r>
+          </a:p>
+        </p:txBody>
+      </p:sp>
+      <p:sp>
+        <p:nvSpPr>
+          <p:cNvPr id="14" name="TextBox 13"/>
+          <p:cNvSpPr txBox="1"/>
+          <p:nvPr/>
+        </p:nvSpPr>
+        <p:spPr>
+          <a:xfrm>
+            <a:off x="6016752" y="1508760"/>
+            <a:ext cx="5623560" cy="4599432"/>
+          </a:xfrm>
+          <a:prstGeom prst="rect">
+            <a:avLst/>
+          </a:prstGeom>
+          <a:noFill/>
+        </p:spPr>
+        <p:txBody>
+          <a:bodyPr wrap="square" anchor="t"/>
+          <a:lstStyle/>
+          <a:p>
+            <a:pPr algn="l"/>
+            <a:r>
+              <a:rPr sz="1600" b="0">
+                <a:solidFill>
+                  <a:srgbClr val="3D4A57"/>
+                </a:solidFill>
+                <a:latin typeface="Calibri"/>
+              </a:rPr>
+              <a:t>Interrupted. Appositional. A tension suture (WCVM).
+The far bite takes the load. The near bite apposes the edge.
+The name is the order of the bites: near-far-far-near, or far-near-near-far.
+Less blood-supply cost than a horizontal mattress, more than a simple interrupted.
+Still fix the real tension first.</a:t>
+            </a:r>
+          </a:p>
+        </p:txBody>
+      </p:sp>
+      <p:sp>
+        <p:nvSpPr>
+          <p:cNvPr id="15" name="Rectangle 14"/>
           <p:cNvSpPr/>
           <p:nvPr/>
         </p:nvSpPr>
@@ -18009,7 +17879,7 @@
       </p:sp>
       <p:sp>
         <p:nvSpPr>
-          <p:cNvPr id="9" name="TextBox 8"/>
+          <p:cNvPr id="16" name="TextBox 15"/>
           <p:cNvSpPr txBox="1"/>
           <p:nvPr/>
         </p:nvSpPr>
@@ -18042,7 +17912,7 @@
       </p:sp>
       <p:sp>
         <p:nvSpPr>
-          <p:cNvPr id="10" name="TextBox 9"/>
+          <p:cNvPr id="17" name="TextBox 16"/>
           <p:cNvSpPr txBox="1"/>
           <p:nvPr/>
         </p:nvSpPr>
@@ -18298,14 +18168,102 @@
       </p:sp>
       <p:sp>
         <p:nvSpPr>
-          <p:cNvPr id="7" name="TextBox 6"/>
+          <p:cNvPr id="7" name="Rounded Rectangle 6"/>
+          <p:cNvSpPr/>
+          <p:nvPr/>
+        </p:nvSpPr>
+        <p:spPr>
+          <a:xfrm>
+            <a:off x="365760" y="1051560"/>
+            <a:ext cx="5212080" cy="5166360"/>
+          </a:xfrm>
+          <a:prstGeom prst="roundRect">
+            <a:avLst>
+              <a:gd name="adj" fmla="val 8000"/>
+            </a:avLst>
+          </a:prstGeom>
+          <a:solidFill>
+            <a:srgbClr val="FFFFFF"/>
+          </a:solidFill>
+          <a:ln>
+            <a:noFill/>
+          </a:ln>
+        </p:spPr>
+        <p:style>
+          <a:lnRef idx="1">
+            <a:schemeClr val="accent1"/>
+          </a:lnRef>
+          <a:fillRef idx="3">
+            <a:schemeClr val="accent1"/>
+          </a:fillRef>
+          <a:effectRef idx="2">
+            <a:schemeClr val="accent1"/>
+          </a:effectRef>
+          <a:fontRef idx="minor">
+            <a:schemeClr val="lt1"/>
+          </a:fontRef>
+        </p:style>
+        <p:txBody>
+          <a:bodyPr rtlCol="0" anchor="ctr"/>
+          <a:lstStyle/>
+          <a:p>
+            <a:pPr algn="ctr"/>
+          </a:p>
+        </p:txBody>
+      </p:sp>
+      <p:sp>
+        <p:nvSpPr>
+          <p:cNvPr id="8" name="Rectangle 7"/>
+          <p:cNvSpPr/>
+          <p:nvPr/>
+        </p:nvSpPr>
+        <p:spPr>
+          <a:xfrm>
+            <a:off x="365760" y="1051560"/>
+            <a:ext cx="5212080" cy="365760"/>
+          </a:xfrm>
+          <a:prstGeom prst="rect">
+            <a:avLst/>
+          </a:prstGeom>
+          <a:solidFill>
+            <a:srgbClr val="0B2C4A"/>
+          </a:solidFill>
+          <a:ln>
+            <a:noFill/>
+          </a:ln>
+        </p:spPr>
+        <p:style>
+          <a:lnRef idx="1">
+            <a:schemeClr val="accent1"/>
+          </a:lnRef>
+          <a:fillRef idx="3">
+            <a:schemeClr val="accent1"/>
+          </a:fillRef>
+          <a:effectRef idx="2">
+            <a:schemeClr val="accent1"/>
+          </a:effectRef>
+          <a:fontRef idx="minor">
+            <a:schemeClr val="lt1"/>
+          </a:fontRef>
+        </p:style>
+        <p:txBody>
+          <a:bodyPr rtlCol="0" anchor="ctr"/>
+          <a:lstStyle/>
+          <a:p>
+            <a:pPr algn="ctr"/>
+          </a:p>
+        </p:txBody>
+      </p:sp>
+      <p:sp>
+        <p:nvSpPr>
+          <p:cNvPr id="9" name="TextBox 8"/>
           <p:cNvSpPr txBox="1"/>
           <p:nvPr/>
         </p:nvSpPr>
         <p:spPr>
           <a:xfrm>
-            <a:off x="502920" y="1143000"/>
-            <a:ext cx="11155680" cy="4937760"/>
+            <a:off x="365760" y="1051560"/>
+            <a:ext cx="5212080" cy="365760"/>
           </a:xfrm>
           <a:prstGeom prst="rect">
             <a:avLst/>
@@ -18313,95 +18271,207 @@
           <a:noFill/>
         </p:spPr>
         <p:txBody>
-          <a:bodyPr wrap="square">
-            <a:spAutoFit/>
-          </a:bodyPr>
-          <a:lstStyle/>
-          <a:p>
-            <a:pPr algn="l">
-              <a:spcAft>
-                <a:spcPts val="1200"/>
-              </a:spcAft>
-            </a:pPr>
-            <a:r>
-              <a:rPr sz="2000">
-                <a:solidFill>
-                  <a:srgbClr val="1C1C1C"/>
-                </a:solidFill>
-                <a:latin typeface="Calibri"/>
-              </a:rPr>
-              <a:t>▸  Continuous. Appositional. Blood-supply cost similar to simple continuous (WCVM).</a:t>
-            </a:r>
-          </a:p>
-          <a:p>
-            <a:pPr algn="l">
-              <a:spcAft>
-                <a:spcPts val="1200"/>
-              </a:spcAft>
-            </a:pPr>
-            <a:r>
-              <a:rPr sz="2000">
-                <a:solidFill>
-                  <a:srgbClr val="1C1C1C"/>
-                </a:solidFill>
-                <a:latin typeface="Calibri"/>
-              </a:rPr>
-              <a:t>▸  Each bite locks. You still have one strand, so one cut can still fail the line.</a:t>
-            </a:r>
-          </a:p>
-          <a:p>
-            <a:pPr algn="l">
-              <a:spcAft>
-                <a:spcPts val="1200"/>
-              </a:spcAft>
-            </a:pPr>
-            <a:r>
-              <a:rPr sz="2000">
-                <a:solidFill>
-                  <a:srgbClr val="1C1C1C"/>
-                </a:solidFill>
-                <a:latin typeface="Calibri"/>
-              </a:rPr>
-              <a:t>▸  Adjust tension with each bite. It is hard to fix at the end.</a:t>
-            </a:r>
-          </a:p>
-          <a:p>
-            <a:pPr algn="l">
-              <a:spcAft>
-                <a:spcPts val="1200"/>
-              </a:spcAft>
-            </a:pPr>
-            <a:r>
-              <a:rPr sz="2000">
-                <a:solidFill>
-                  <a:srgbClr val="1C1C1C"/>
-                </a:solidFill>
-                <a:latin typeface="Calibri"/>
-              </a:rPr>
-              <a:t>▸  Finish by making a loop and tying, or by a bite through intact skin off the incision (WCVM options A and B).</a:t>
-            </a:r>
-          </a:p>
-          <a:p>
-            <a:pPr algn="l">
-              <a:spcAft>
-                <a:spcPts val="1200"/>
-              </a:spcAft>
-            </a:pPr>
-            <a:r>
-              <a:rPr sz="2000">
-                <a:solidFill>
-                  <a:srgbClr val="1C1C1C"/>
-                </a:solidFill>
-                <a:latin typeface="Calibri"/>
-              </a:rPr>
-              <a:t>▸  A compromise between interrupted security and continuous speed. Not a reason to skip undermining.</a:t>
-            </a:r>
-          </a:p>
-        </p:txBody>
-      </p:sp>
-      <p:sp>
-        <p:nvSpPr>
-          <p:cNvPr id="8" name="Rectangle 7"/>
+          <a:bodyPr wrap="square" anchor="ctr"/>
+          <a:lstStyle/>
+          <a:p>
+            <a:pPr algn="ctr"/>
+            <a:r>
+              <a:rPr sz="1400" b="1">
+                <a:solidFill>
+                  <a:srgbClr val="C5A35A"/>
+                </a:solidFill>
+                <a:latin typeface="Calibri"/>
+              </a:rPr>
+              <a:t>Original 3D teaching figure</a:t>
+            </a:r>
+          </a:p>
+        </p:txBody>
+      </p:sp>
+      <p:pic>
+        <p:nvPicPr>
+          <p:cNvPr id="10" name="Picture 9" descr="suture3d_ford.png"/>
+          <p:cNvPicPr>
+            <a:picLocks noChangeAspect="1"/>
+          </p:cNvPicPr>
+          <p:nvPr/>
+        </p:nvPicPr>
+        <p:blipFill>
+          <a:blip r:embed="rId2"/>
+          <a:stretch>
+            <a:fillRect/>
+          </a:stretch>
+        </p:blipFill>
+        <p:spPr>
+          <a:xfrm>
+            <a:off x="493776" y="1940814"/>
+            <a:ext cx="4956048" cy="3717036"/>
+          </a:xfrm>
+          <a:prstGeom prst="rect">
+            <a:avLst/>
+          </a:prstGeom>
+        </p:spPr>
+      </p:pic>
+      <p:sp>
+        <p:nvSpPr>
+          <p:cNvPr id="11" name="Rounded Rectangle 10"/>
+          <p:cNvSpPr/>
+          <p:nvPr/>
+        </p:nvSpPr>
+        <p:spPr>
+          <a:xfrm>
+            <a:off x="5760720" y="1051560"/>
+            <a:ext cx="5989320" cy="5166360"/>
+          </a:xfrm>
+          <a:prstGeom prst="roundRect">
+            <a:avLst>
+              <a:gd name="adj" fmla="val 8000"/>
+            </a:avLst>
+          </a:prstGeom>
+          <a:solidFill>
+            <a:srgbClr val="FFFFFF"/>
+          </a:solidFill>
+          <a:ln>
+            <a:noFill/>
+          </a:ln>
+        </p:spPr>
+        <p:style>
+          <a:lnRef idx="1">
+            <a:schemeClr val="accent1"/>
+          </a:lnRef>
+          <a:fillRef idx="3">
+            <a:schemeClr val="accent1"/>
+          </a:fillRef>
+          <a:effectRef idx="2">
+            <a:schemeClr val="accent1"/>
+          </a:effectRef>
+          <a:fontRef idx="minor">
+            <a:schemeClr val="lt1"/>
+          </a:fontRef>
+        </p:style>
+        <p:txBody>
+          <a:bodyPr rtlCol="0" anchor="ctr"/>
+          <a:lstStyle/>
+          <a:p>
+            <a:pPr algn="ctr"/>
+          </a:p>
+        </p:txBody>
+      </p:sp>
+      <p:sp>
+        <p:nvSpPr>
+          <p:cNvPr id="12" name="Rectangle 11"/>
+          <p:cNvSpPr/>
+          <p:nvPr/>
+        </p:nvSpPr>
+        <p:spPr>
+          <a:xfrm>
+            <a:off x="5760720" y="1051560"/>
+            <a:ext cx="91440" cy="5166360"/>
+          </a:xfrm>
+          <a:prstGeom prst="rect">
+            <a:avLst/>
+          </a:prstGeom>
+          <a:solidFill>
+            <a:srgbClr val="0B2C4A"/>
+          </a:solidFill>
+          <a:ln>
+            <a:noFill/>
+          </a:ln>
+        </p:spPr>
+        <p:style>
+          <a:lnRef idx="1">
+            <a:schemeClr val="accent1"/>
+          </a:lnRef>
+          <a:fillRef idx="3">
+            <a:schemeClr val="accent1"/>
+          </a:fillRef>
+          <a:effectRef idx="2">
+            <a:schemeClr val="accent1"/>
+          </a:effectRef>
+          <a:fontRef idx="minor">
+            <a:schemeClr val="lt1"/>
+          </a:fontRef>
+        </p:style>
+        <p:txBody>
+          <a:bodyPr rtlCol="0" anchor="ctr"/>
+          <a:lstStyle/>
+          <a:p>
+            <a:pPr algn="ctr"/>
+          </a:p>
+        </p:txBody>
+      </p:sp>
+      <p:sp>
+        <p:nvSpPr>
+          <p:cNvPr id="13" name="TextBox 12"/>
+          <p:cNvSpPr txBox="1"/>
+          <p:nvPr/>
+        </p:nvSpPr>
+        <p:spPr>
+          <a:xfrm>
+            <a:off x="6016752" y="1161288"/>
+            <a:ext cx="5623560" cy="329184"/>
+          </a:xfrm>
+          <a:prstGeom prst="rect">
+            <a:avLst/>
+          </a:prstGeom>
+          <a:noFill/>
+        </p:spPr>
+        <p:txBody>
+          <a:bodyPr wrap="square" anchor="t"/>
+          <a:lstStyle/>
+          <a:p>
+            <a:pPr algn="l"/>
+            <a:r>
+              <a:rPr sz="1800" b="1">
+                <a:solidFill>
+                  <a:srgbClr val="0B2C4A"/>
+                </a:solidFill>
+                <a:latin typeface="Calibri"/>
+              </a:rPr>
+              <a:t>What to say</a:t>
+            </a:r>
+          </a:p>
+        </p:txBody>
+      </p:sp>
+      <p:sp>
+        <p:nvSpPr>
+          <p:cNvPr id="14" name="TextBox 13"/>
+          <p:cNvSpPr txBox="1"/>
+          <p:nvPr/>
+        </p:nvSpPr>
+        <p:spPr>
+          <a:xfrm>
+            <a:off x="6016752" y="1508760"/>
+            <a:ext cx="5623560" cy="4599432"/>
+          </a:xfrm>
+          <a:prstGeom prst="rect">
+            <a:avLst/>
+          </a:prstGeom>
+          <a:noFill/>
+        </p:spPr>
+        <p:txBody>
+          <a:bodyPr wrap="square" anchor="t"/>
+          <a:lstStyle/>
+          <a:p>
+            <a:pPr algn="l"/>
+            <a:r>
+              <a:rPr sz="1600" b="0">
+                <a:solidFill>
+                  <a:srgbClr val="3D4A57"/>
+                </a:solidFill>
+                <a:latin typeface="Calibri"/>
+              </a:rPr>
+              <a:t>Continuous. Appositional. Blood-supply cost similar to simple continuous (WCVM).
+Each bite locks. You still have one strand, so one cut can still fail the line.
+Adjust tension with each bite. It is hard to fix at the end.
+Finish by making a loop and tying, or by a bite through intact skin off the incision (WCVM options A and B).
+Not a reason to skip undermining.</a:t>
+            </a:r>
+          </a:p>
+        </p:txBody>
+      </p:sp>
+      <p:sp>
+        <p:nvSpPr>
+          <p:cNvPr id="15" name="Rectangle 14"/>
           <p:cNvSpPr/>
           <p:nvPr/>
         </p:nvSpPr>
@@ -18444,7 +18514,7 @@
       </p:sp>
       <p:sp>
         <p:nvSpPr>
-          <p:cNvPr id="9" name="TextBox 8"/>
+          <p:cNvPr id="16" name="TextBox 15"/>
           <p:cNvSpPr txBox="1"/>
           <p:nvPr/>
         </p:nvSpPr>
@@ -18477,7 +18547,7 @@
       </p:sp>
       <p:sp>
         <p:nvSpPr>
-          <p:cNvPr id="10" name="TextBox 9"/>
+          <p:cNvPr id="17" name="TextBox 16"/>
           <p:cNvSpPr txBox="1"/>
           <p:nvPr/>
         </p:nvSpPr>
@@ -18739,8 +18809,8 @@
         </p:nvSpPr>
         <p:spPr>
           <a:xfrm>
-            <a:off x="411480" y="1097280"/>
-            <a:ext cx="5623560" cy="5120640"/>
+            <a:off x="365760" y="1051560"/>
+            <a:ext cx="5212080" cy="5166360"/>
           </a:xfrm>
           <a:prstGeom prst="roundRect">
             <a:avLst>
@@ -18784,14 +18854,14 @@
         </p:nvSpPr>
         <p:spPr>
           <a:xfrm>
-            <a:off x="411480" y="1097280"/>
-            <a:ext cx="91440" cy="5120640"/>
-          </a:xfrm>
-          <a:prstGeom prst="rect">
-            <a:avLst/>
-          </a:prstGeom>
-          <a:solidFill>
-            <a:srgbClr val="C5A35A"/>
+            <a:off x="365760" y="1051560"/>
+            <a:ext cx="5212080" cy="365760"/>
+          </a:xfrm>
+          <a:prstGeom prst="rect">
+            <a:avLst/>
+          </a:prstGeom>
+          <a:solidFill>
+            <a:srgbClr val="0B2C4A"/>
           </a:solidFill>
           <a:ln>
             <a:noFill/>
@@ -18827,8 +18897,8 @@
         </p:nvSpPr>
         <p:spPr>
           <a:xfrm>
-            <a:off x="667512" y="1207008"/>
-            <a:ext cx="5257800" cy="329184"/>
+            <a:off x="365760" y="1051560"/>
+            <a:ext cx="5212080" cy="365760"/>
           </a:xfrm>
           <a:prstGeom prst="rect">
             <a:avLst/>
@@ -18836,57 +18906,46 @@
           <a:noFill/>
         </p:spPr>
         <p:txBody>
-          <a:bodyPr wrap="square" anchor="t"/>
-          <a:lstStyle/>
-          <a:p>
-            <a:pPr algn="l"/>
-            <a:r>
-              <a:rPr sz="1800" b="1">
-                <a:solidFill>
-                  <a:srgbClr val="0B2C4A"/>
-                </a:solidFill>
-                <a:latin typeface="Calibri"/>
-              </a:rPr>
-              <a:t>What it is</a:t>
-            </a:r>
-          </a:p>
-        </p:txBody>
-      </p:sp>
-      <p:sp>
-        <p:nvSpPr>
-          <p:cNvPr id="10" name="TextBox 9"/>
-          <p:cNvSpPr txBox="1"/>
-          <p:nvPr/>
-        </p:nvSpPr>
-        <p:spPr>
-          <a:xfrm>
-            <a:off x="667512" y="1554480"/>
-            <a:ext cx="5257800" cy="4553712"/>
-          </a:xfrm>
-          <a:prstGeom prst="rect">
-            <a:avLst/>
-          </a:prstGeom>
-          <a:noFill/>
-        </p:spPr>
-        <p:txBody>
-          <a:bodyPr wrap="square" anchor="t"/>
-          <a:lstStyle/>
-          <a:p>
-            <a:pPr algn="l"/>
-            <a:r>
-              <a:rPr sz="1600" b="0">
-                <a:solidFill>
-                  <a:srgbClr val="3D4A57"/>
-                </a:solidFill>
-                <a:latin typeface="Calibri"/>
-              </a:rPr>
-              <a:t>Continuous. Appositional. Bites live in the dermis, as close to the surface as you can place them without exiting skin (WCVM).
-Successive bites backtrack. Buried knots at both ends.
-Minimal impact on skin blood supply if you do not strangulate.</a:t>
-            </a:r>
-          </a:p>
-        </p:txBody>
-      </p:sp>
+          <a:bodyPr wrap="square" anchor="ctr"/>
+          <a:lstStyle/>
+          <a:p>
+            <a:pPr algn="ctr"/>
+            <a:r>
+              <a:rPr sz="1400" b="1">
+                <a:solidFill>
+                  <a:srgbClr val="C5A35A"/>
+                </a:solidFill>
+                <a:latin typeface="Calibri"/>
+              </a:rPr>
+              <a:t>Original 3D teaching figure</a:t>
+            </a:r>
+          </a:p>
+        </p:txBody>
+      </p:sp>
+      <p:pic>
+        <p:nvPicPr>
+          <p:cNvPr id="10" name="Picture 9" descr="suture3d_intradermal.png"/>
+          <p:cNvPicPr>
+            <a:picLocks noChangeAspect="1"/>
+          </p:cNvPicPr>
+          <p:nvPr/>
+        </p:nvPicPr>
+        <p:blipFill>
+          <a:blip r:embed="rId2"/>
+          <a:stretch>
+            <a:fillRect/>
+          </a:stretch>
+        </p:blipFill>
+        <p:spPr>
+          <a:xfrm>
+            <a:off x="493776" y="1940814"/>
+            <a:ext cx="4956048" cy="3717036"/>
+          </a:xfrm>
+          <a:prstGeom prst="rect">
+            <a:avLst/>
+          </a:prstGeom>
+        </p:spPr>
+      </p:pic>
       <p:sp>
         <p:nvSpPr>
           <p:cNvPr id="11" name="Rounded Rectangle 10"/>
@@ -18895,8 +18954,8 @@
         </p:nvSpPr>
         <p:spPr>
           <a:xfrm>
-            <a:off x="6217920" y="1097280"/>
-            <a:ext cx="5532120" cy="5120640"/>
+            <a:off x="5760720" y="1051560"/>
+            <a:ext cx="5989320" cy="2468880"/>
           </a:xfrm>
           <a:prstGeom prst="roundRect">
             <a:avLst>
@@ -18940,14 +18999,14 @@
         </p:nvSpPr>
         <p:spPr>
           <a:xfrm>
-            <a:off x="6217920" y="1097280"/>
-            <a:ext cx="91440" cy="5120640"/>
-          </a:xfrm>
-          <a:prstGeom prst="rect">
-            <a:avLst/>
-          </a:prstGeom>
-          <a:solidFill>
-            <a:srgbClr val="0B2C4A"/>
+            <a:off x="5760720" y="1051560"/>
+            <a:ext cx="91440" cy="2468880"/>
+          </a:xfrm>
+          <a:prstGeom prst="rect">
+            <a:avLst/>
+          </a:prstGeom>
+          <a:solidFill>
+            <a:srgbClr val="C5A35A"/>
           </a:solidFill>
           <a:ln>
             <a:noFill/>
@@ -18983,8 +19042,8 @@
         </p:nvSpPr>
         <p:spPr>
           <a:xfrm>
-            <a:off x="6473952" y="1207008"/>
-            <a:ext cx="5166360" cy="329184"/>
+            <a:off x="6016752" y="1161288"/>
+            <a:ext cx="5623560" cy="329184"/>
           </a:xfrm>
           <a:prstGeom prst="rect">
             <a:avLst/>
@@ -19003,7 +19062,7 @@
                 </a:solidFill>
                 <a:latin typeface="Calibri"/>
               </a:rPr>
-              <a:t>What it is not</a:t>
+              <a:t>What it is</a:t>
             </a:r>
           </a:p>
         </p:txBody>
@@ -19016,8 +19075,8 @@
         </p:nvSpPr>
         <p:spPr>
           <a:xfrm>
-            <a:off x="6473952" y="1554480"/>
-            <a:ext cx="5166360" cy="4553712"/>
+            <a:off x="6016752" y="1508760"/>
+            <a:ext cx="5623560" cy="1901952"/>
           </a:xfrm>
           <a:prstGeom prst="rect">
             <a:avLst/>
@@ -19036,9 +19095,162 @@
                 </a:solidFill>
                 <a:latin typeface="Calibri"/>
               </a:rPr>
-              <a:t>It is not a substitute for a dead-space layer.
-It is not a reason to skip an E-collar conversation.
-Forceps crushing the dermis leaves a bruise. WCVM: stabilize with thumb and finger, palm the forceps.
+              <a:t>Continuous. Appositional. Bites live in the dermis, as close to the surface as you can place them without exiting skin (WCVM).
+Successive bites backtrack. Buried knots at both ends.</a:t>
+            </a:r>
+          </a:p>
+        </p:txBody>
+      </p:sp>
+      <p:sp>
+        <p:nvSpPr>
+          <p:cNvPr id="15" name="Rounded Rectangle 14"/>
+          <p:cNvSpPr/>
+          <p:nvPr/>
+        </p:nvSpPr>
+        <p:spPr>
+          <a:xfrm>
+            <a:off x="5760720" y="3703320"/>
+            <a:ext cx="5989320" cy="2514600"/>
+          </a:xfrm>
+          <a:prstGeom prst="roundRect">
+            <a:avLst>
+              <a:gd name="adj" fmla="val 8000"/>
+            </a:avLst>
+          </a:prstGeom>
+          <a:solidFill>
+            <a:srgbClr val="FFFFFF"/>
+          </a:solidFill>
+          <a:ln>
+            <a:noFill/>
+          </a:ln>
+        </p:spPr>
+        <p:style>
+          <a:lnRef idx="1">
+            <a:schemeClr val="accent1"/>
+          </a:lnRef>
+          <a:fillRef idx="3">
+            <a:schemeClr val="accent1"/>
+          </a:fillRef>
+          <a:effectRef idx="2">
+            <a:schemeClr val="accent1"/>
+          </a:effectRef>
+          <a:fontRef idx="minor">
+            <a:schemeClr val="lt1"/>
+          </a:fontRef>
+        </p:style>
+        <p:txBody>
+          <a:bodyPr rtlCol="0" anchor="ctr"/>
+          <a:lstStyle/>
+          <a:p>
+            <a:pPr algn="ctr"/>
+          </a:p>
+        </p:txBody>
+      </p:sp>
+      <p:sp>
+        <p:nvSpPr>
+          <p:cNvPr id="16" name="Rectangle 15"/>
+          <p:cNvSpPr/>
+          <p:nvPr/>
+        </p:nvSpPr>
+        <p:spPr>
+          <a:xfrm>
+            <a:off x="5760720" y="3703320"/>
+            <a:ext cx="91440" cy="2514600"/>
+          </a:xfrm>
+          <a:prstGeom prst="rect">
+            <a:avLst/>
+          </a:prstGeom>
+          <a:solidFill>
+            <a:srgbClr val="0B2C4A"/>
+          </a:solidFill>
+          <a:ln>
+            <a:noFill/>
+          </a:ln>
+        </p:spPr>
+        <p:style>
+          <a:lnRef idx="1">
+            <a:schemeClr val="accent1"/>
+          </a:lnRef>
+          <a:fillRef idx="3">
+            <a:schemeClr val="accent1"/>
+          </a:fillRef>
+          <a:effectRef idx="2">
+            <a:schemeClr val="accent1"/>
+          </a:effectRef>
+          <a:fontRef idx="minor">
+            <a:schemeClr val="lt1"/>
+          </a:fontRef>
+        </p:style>
+        <p:txBody>
+          <a:bodyPr rtlCol="0" anchor="ctr"/>
+          <a:lstStyle/>
+          <a:p>
+            <a:pPr algn="ctr"/>
+          </a:p>
+        </p:txBody>
+      </p:sp>
+      <p:sp>
+        <p:nvSpPr>
+          <p:cNvPr id="17" name="TextBox 16"/>
+          <p:cNvSpPr txBox="1"/>
+          <p:nvPr/>
+        </p:nvSpPr>
+        <p:spPr>
+          <a:xfrm>
+            <a:off x="6016752" y="3813048"/>
+            <a:ext cx="5623560" cy="329184"/>
+          </a:xfrm>
+          <a:prstGeom prst="rect">
+            <a:avLst/>
+          </a:prstGeom>
+          <a:noFill/>
+        </p:spPr>
+        <p:txBody>
+          <a:bodyPr wrap="square" anchor="t"/>
+          <a:lstStyle/>
+          <a:p>
+            <a:pPr algn="l"/>
+            <a:r>
+              <a:rPr sz="1800" b="1">
+                <a:solidFill>
+                  <a:srgbClr val="0B2C4A"/>
+                </a:solidFill>
+                <a:latin typeface="Calibri"/>
+              </a:rPr>
+              <a:t>What it is not</a:t>
+            </a:r>
+          </a:p>
+        </p:txBody>
+      </p:sp>
+      <p:sp>
+        <p:nvSpPr>
+          <p:cNvPr id="18" name="TextBox 17"/>
+          <p:cNvSpPr txBox="1"/>
+          <p:nvPr/>
+        </p:nvSpPr>
+        <p:spPr>
+          <a:xfrm>
+            <a:off x="6016752" y="4160520"/>
+            <a:ext cx="5623560" cy="1947672"/>
+          </a:xfrm>
+          <a:prstGeom prst="rect">
+            <a:avLst/>
+          </a:prstGeom>
+          <a:noFill/>
+        </p:spPr>
+        <p:txBody>
+          <a:bodyPr wrap="square" anchor="t"/>
+          <a:lstStyle/>
+          <a:p>
+            <a:pPr algn="l"/>
+            <a:r>
+              <a:rPr sz="1600" b="0">
+                <a:solidFill>
+                  <a:srgbClr val="3D4A57"/>
+                </a:solidFill>
+                <a:latin typeface="Calibri"/>
+              </a:rPr>
+              <a:t>Not a substitute for a dead-space layer. Not a reason to skip an E-collar conversation.
 Burying the knot is a lab skill (WCVM Part 5). Week 8 owns the knot.</a:t>
             </a:r>
           </a:p>
@@ -19046,7 +19258,7 @@
       </p:sp>
       <p:sp>
         <p:nvSpPr>
-          <p:cNvPr id="15" name="Rectangle 14"/>
+          <p:cNvPr id="19" name="Rectangle 18"/>
           <p:cNvSpPr/>
           <p:nvPr/>
         </p:nvSpPr>
@@ -19089,7 +19301,7 @@
       </p:sp>
       <p:sp>
         <p:nvSpPr>
-          <p:cNvPr id="16" name="TextBox 15"/>
+          <p:cNvPr id="20" name="TextBox 19"/>
           <p:cNvSpPr txBox="1"/>
           <p:nvPr/>
         </p:nvSpPr>
@@ -19122,7 +19334,7 @@
       </p:sp>
       <p:sp>
         <p:nvSpPr>
-          <p:cNvPr id="17" name="TextBox 16"/>
+          <p:cNvPr id="21" name="TextBox 20"/>
           <p:cNvSpPr txBox="1"/>
           <p:nvPr/>
         </p:nvSpPr>
@@ -19378,14 +19590,102 @@
       </p:sp>
       <p:sp>
         <p:nvSpPr>
-          <p:cNvPr id="7" name="TextBox 6"/>
+          <p:cNvPr id="7" name="Rounded Rectangle 6"/>
+          <p:cNvSpPr/>
+          <p:nvPr/>
+        </p:nvSpPr>
+        <p:spPr>
+          <a:xfrm>
+            <a:off x="365760" y="1051560"/>
+            <a:ext cx="5212080" cy="5166360"/>
+          </a:xfrm>
+          <a:prstGeom prst="roundRect">
+            <a:avLst>
+              <a:gd name="adj" fmla="val 8000"/>
+            </a:avLst>
+          </a:prstGeom>
+          <a:solidFill>
+            <a:srgbClr val="FFFFFF"/>
+          </a:solidFill>
+          <a:ln>
+            <a:noFill/>
+          </a:ln>
+        </p:spPr>
+        <p:style>
+          <a:lnRef idx="1">
+            <a:schemeClr val="accent1"/>
+          </a:lnRef>
+          <a:fillRef idx="3">
+            <a:schemeClr val="accent1"/>
+          </a:fillRef>
+          <a:effectRef idx="2">
+            <a:schemeClr val="accent1"/>
+          </a:effectRef>
+          <a:fontRef idx="minor">
+            <a:schemeClr val="lt1"/>
+          </a:fontRef>
+        </p:style>
+        <p:txBody>
+          <a:bodyPr rtlCol="0" anchor="ctr"/>
+          <a:lstStyle/>
+          <a:p>
+            <a:pPr algn="ctr"/>
+          </a:p>
+        </p:txBody>
+      </p:sp>
+      <p:sp>
+        <p:nvSpPr>
+          <p:cNvPr id="8" name="Rectangle 7"/>
+          <p:cNvSpPr/>
+          <p:nvPr/>
+        </p:nvSpPr>
+        <p:spPr>
+          <a:xfrm>
+            <a:off x="365760" y="1051560"/>
+            <a:ext cx="5212080" cy="365760"/>
+          </a:xfrm>
+          <a:prstGeom prst="rect">
+            <a:avLst/>
+          </a:prstGeom>
+          <a:solidFill>
+            <a:srgbClr val="0B2C4A"/>
+          </a:solidFill>
+          <a:ln>
+            <a:noFill/>
+          </a:ln>
+        </p:spPr>
+        <p:style>
+          <a:lnRef idx="1">
+            <a:schemeClr val="accent1"/>
+          </a:lnRef>
+          <a:fillRef idx="3">
+            <a:schemeClr val="accent1"/>
+          </a:fillRef>
+          <a:effectRef idx="2">
+            <a:schemeClr val="accent1"/>
+          </a:effectRef>
+          <a:fontRef idx="minor">
+            <a:schemeClr val="lt1"/>
+          </a:fontRef>
+        </p:style>
+        <p:txBody>
+          <a:bodyPr rtlCol="0" anchor="ctr"/>
+          <a:lstStyle/>
+          <a:p>
+            <a:pPr algn="ctr"/>
+          </a:p>
+        </p:txBody>
+      </p:sp>
+      <p:sp>
+        <p:nvSpPr>
+          <p:cNvPr id="9" name="TextBox 8"/>
           <p:cNvSpPr txBox="1"/>
           <p:nvPr/>
         </p:nvSpPr>
         <p:spPr>
           <a:xfrm>
-            <a:off x="502920" y="1143000"/>
-            <a:ext cx="11155680" cy="4937760"/>
+            <a:off x="365760" y="1051560"/>
+            <a:ext cx="5212080" cy="365760"/>
           </a:xfrm>
           <a:prstGeom prst="rect">
             <a:avLst/>
@@ -19393,95 +19693,207 @@
           <a:noFill/>
         </p:spPr>
         <p:txBody>
-          <a:bodyPr wrap="square">
-            <a:spAutoFit/>
-          </a:bodyPr>
-          <a:lstStyle/>
-          <a:p>
-            <a:pPr algn="l">
-              <a:spcAft>
-                <a:spcPts val="1200"/>
-              </a:spcAft>
-            </a:pPr>
-            <a:r>
-              <a:rPr sz="2000">
-                <a:solidFill>
-                  <a:srgbClr val="1C1C1C"/>
-                </a:solidFill>
-                <a:latin typeface="Calibri"/>
-              </a:rPr>
-              <a:t>▸  Usually continuous. Inverting. Bites run perpendicular to the incision: transverse Lembert (WCVM).</a:t>
-            </a:r>
-          </a:p>
-          <a:p>
-            <a:pPr algn="l">
-              <a:spcAft>
-                <a:spcPts val="1200"/>
-              </a:spcAft>
-            </a:pPr>
-            <a:r>
-              <a:rPr sz="2000">
-                <a:solidFill>
-                  <a:srgbClr val="1C1C1C"/>
-                </a:solidFill>
-                <a:latin typeface="Calibri"/>
-              </a:rPr>
-              <a:t>▸  On a hollow organ: serosa, muscularis, and submucosa. Not through mucosa.</a:t>
-            </a:r>
-          </a:p>
-          <a:p>
-            <a:pPr algn="l">
-              <a:spcAft>
-                <a:spcPts val="1200"/>
-              </a:spcAft>
-            </a:pPr>
-            <a:r>
-              <a:rPr sz="2000">
-                <a:solidFill>
-                  <a:srgbClr val="1C1C1C"/>
-                </a:solidFill>
-                <a:latin typeface="Calibri"/>
-              </a:rPr>
-              <a:t>▸  Farther from the edge means more inversion and a smaller lumen.</a:t>
-            </a:r>
-          </a:p>
-          <a:p>
-            <a:pPr algn="l">
-              <a:spcAft>
-                <a:spcPts val="1200"/>
-              </a:spcAft>
-            </a:pPr>
-            <a:r>
-              <a:rPr sz="2000">
-                <a:solidFill>
-                  <a:srgbClr val="1C1C1C"/>
-                </a:solidFill>
-                <a:latin typeface="Calibri"/>
-              </a:rPr>
-              <a:t>▸  More blood-supply cost than a simple continuous.</a:t>
-            </a:r>
-          </a:p>
-          <a:p>
-            <a:pPr algn="l">
-              <a:spcAft>
-                <a:spcPts val="1200"/>
-              </a:spcAft>
-            </a:pPr>
-            <a:r>
-              <a:rPr sz="2000">
-                <a:solidFill>
-                  <a:srgbClr val="1C1C1C"/>
-                </a:solidFill>
-                <a:latin typeface="Calibri"/>
-              </a:rPr>
-              <a:t>▸  Confirm the organ and the lumen size before you invert. A small-intestine lumen is not a stomach lumen.</a:t>
-            </a:r>
-          </a:p>
-        </p:txBody>
-      </p:sp>
-      <p:sp>
-        <p:nvSpPr>
-          <p:cNvPr id="8" name="Rectangle 7"/>
+          <a:bodyPr wrap="square" anchor="ctr"/>
+          <a:lstStyle/>
+          <a:p>
+            <a:pPr algn="ctr"/>
+            <a:r>
+              <a:rPr sz="1400" b="1">
+                <a:solidFill>
+                  <a:srgbClr val="C5A35A"/>
+                </a:solidFill>
+                <a:latin typeface="Calibri"/>
+              </a:rPr>
+              <a:t>Original 3D teaching figure</a:t>
+            </a:r>
+          </a:p>
+        </p:txBody>
+      </p:sp>
+      <p:pic>
+        <p:nvPicPr>
+          <p:cNvPr id="10" name="Picture 9" descr="suture3d_lembert.png"/>
+          <p:cNvPicPr>
+            <a:picLocks noChangeAspect="1"/>
+          </p:cNvPicPr>
+          <p:nvPr/>
+        </p:nvPicPr>
+        <p:blipFill>
+          <a:blip r:embed="rId2"/>
+          <a:stretch>
+            <a:fillRect/>
+          </a:stretch>
+        </p:blipFill>
+        <p:spPr>
+          <a:xfrm>
+            <a:off x="493776" y="1940814"/>
+            <a:ext cx="4956048" cy="3717036"/>
+          </a:xfrm>
+          <a:prstGeom prst="rect">
+            <a:avLst/>
+          </a:prstGeom>
+        </p:spPr>
+      </p:pic>
+      <p:sp>
+        <p:nvSpPr>
+          <p:cNvPr id="11" name="Rounded Rectangle 10"/>
+          <p:cNvSpPr/>
+          <p:nvPr/>
+        </p:nvSpPr>
+        <p:spPr>
+          <a:xfrm>
+            <a:off x="5760720" y="1051560"/>
+            <a:ext cx="5989320" cy="5166360"/>
+          </a:xfrm>
+          <a:prstGeom prst="roundRect">
+            <a:avLst>
+              <a:gd name="adj" fmla="val 8000"/>
+            </a:avLst>
+          </a:prstGeom>
+          <a:solidFill>
+            <a:srgbClr val="FFFFFF"/>
+          </a:solidFill>
+          <a:ln>
+            <a:noFill/>
+          </a:ln>
+        </p:spPr>
+        <p:style>
+          <a:lnRef idx="1">
+            <a:schemeClr val="accent1"/>
+          </a:lnRef>
+          <a:fillRef idx="3">
+            <a:schemeClr val="accent1"/>
+          </a:fillRef>
+          <a:effectRef idx="2">
+            <a:schemeClr val="accent1"/>
+          </a:effectRef>
+          <a:fontRef idx="minor">
+            <a:schemeClr val="lt1"/>
+          </a:fontRef>
+        </p:style>
+        <p:txBody>
+          <a:bodyPr rtlCol="0" anchor="ctr"/>
+          <a:lstStyle/>
+          <a:p>
+            <a:pPr algn="ctr"/>
+          </a:p>
+        </p:txBody>
+      </p:sp>
+      <p:sp>
+        <p:nvSpPr>
+          <p:cNvPr id="12" name="Rectangle 11"/>
+          <p:cNvSpPr/>
+          <p:nvPr/>
+        </p:nvSpPr>
+        <p:spPr>
+          <a:xfrm>
+            <a:off x="5760720" y="1051560"/>
+            <a:ext cx="91440" cy="5166360"/>
+          </a:xfrm>
+          <a:prstGeom prst="rect">
+            <a:avLst/>
+          </a:prstGeom>
+          <a:solidFill>
+            <a:srgbClr val="C5A35A"/>
+          </a:solidFill>
+          <a:ln>
+            <a:noFill/>
+          </a:ln>
+        </p:spPr>
+        <p:style>
+          <a:lnRef idx="1">
+            <a:schemeClr val="accent1"/>
+          </a:lnRef>
+          <a:fillRef idx="3">
+            <a:schemeClr val="accent1"/>
+          </a:fillRef>
+          <a:effectRef idx="2">
+            <a:schemeClr val="accent1"/>
+          </a:effectRef>
+          <a:fontRef idx="minor">
+            <a:schemeClr val="lt1"/>
+          </a:fontRef>
+        </p:style>
+        <p:txBody>
+          <a:bodyPr rtlCol="0" anchor="ctr"/>
+          <a:lstStyle/>
+          <a:p>
+            <a:pPr algn="ctr"/>
+          </a:p>
+        </p:txBody>
+      </p:sp>
+      <p:sp>
+        <p:nvSpPr>
+          <p:cNvPr id="13" name="TextBox 12"/>
+          <p:cNvSpPr txBox="1"/>
+          <p:nvPr/>
+        </p:nvSpPr>
+        <p:spPr>
+          <a:xfrm>
+            <a:off x="6016752" y="1161288"/>
+            <a:ext cx="5623560" cy="329184"/>
+          </a:xfrm>
+          <a:prstGeom prst="rect">
+            <a:avLst/>
+          </a:prstGeom>
+          <a:noFill/>
+        </p:spPr>
+        <p:txBody>
+          <a:bodyPr wrap="square" anchor="t"/>
+          <a:lstStyle/>
+          <a:p>
+            <a:pPr algn="l"/>
+            <a:r>
+              <a:rPr sz="1800" b="1">
+                <a:solidFill>
+                  <a:srgbClr val="0B2C4A"/>
+                </a:solidFill>
+                <a:latin typeface="Calibri"/>
+              </a:rPr>
+              <a:t>What to say</a:t>
+            </a:r>
+          </a:p>
+        </p:txBody>
+      </p:sp>
+      <p:sp>
+        <p:nvSpPr>
+          <p:cNvPr id="14" name="TextBox 13"/>
+          <p:cNvSpPr txBox="1"/>
+          <p:nvPr/>
+        </p:nvSpPr>
+        <p:spPr>
+          <a:xfrm>
+            <a:off x="6016752" y="1508760"/>
+            <a:ext cx="5623560" cy="4599432"/>
+          </a:xfrm>
+          <a:prstGeom prst="rect">
+            <a:avLst/>
+          </a:prstGeom>
+          <a:noFill/>
+        </p:spPr>
+        <p:txBody>
+          <a:bodyPr wrap="square" anchor="t"/>
+          <a:lstStyle/>
+          <a:p>
+            <a:pPr algn="l"/>
+            <a:r>
+              <a:rPr sz="1600" b="0">
+                <a:solidFill>
+                  <a:srgbClr val="3D4A57"/>
+                </a:solidFill>
+                <a:latin typeface="Calibri"/>
+              </a:rPr>
+              <a:t>Usually continuous. Inverting. Bites run perpendicular to the incision: transverse Lembert (WCVM).
+On a hollow organ: serosa, muscularis, and submucosa. Not through mucosa.
+Farther from the edge means more inversion and a smaller lumen.
+More blood-supply cost than a simple continuous.
+Confirm the organ and the lumen size before you invert.</a:t>
+            </a:r>
+          </a:p>
+        </p:txBody>
+      </p:sp>
+      <p:sp>
+        <p:nvSpPr>
+          <p:cNvPr id="15" name="Rectangle 14"/>
           <p:cNvSpPr/>
           <p:nvPr/>
         </p:nvSpPr>
@@ -19524,7 +19936,7 @@
       </p:sp>
       <p:sp>
         <p:nvSpPr>
-          <p:cNvPr id="9" name="TextBox 8"/>
+          <p:cNvPr id="16" name="TextBox 15"/>
           <p:cNvSpPr txBox="1"/>
           <p:nvPr/>
         </p:nvSpPr>
@@ -19557,7 +19969,7 @@
       </p:sp>
       <p:sp>
         <p:nvSpPr>
-          <p:cNvPr id="10" name="TextBox 9"/>
+          <p:cNvPr id="17" name="TextBox 16"/>
           <p:cNvSpPr txBox="1"/>
           <p:nvPr/>
         </p:nvSpPr>
@@ -19819,8 +20231,8 @@
         </p:nvSpPr>
         <p:spPr>
           <a:xfrm>
-            <a:off x="411480" y="1097280"/>
-            <a:ext cx="5623560" cy="5120640"/>
+            <a:off x="365760" y="1051560"/>
+            <a:ext cx="5623560" cy="2788920"/>
           </a:xfrm>
           <a:prstGeom prst="roundRect">
             <a:avLst>
@@ -19864,14 +20276,14 @@
         </p:nvSpPr>
         <p:spPr>
           <a:xfrm>
-            <a:off x="411480" y="1097280"/>
-            <a:ext cx="91440" cy="5120640"/>
-          </a:xfrm>
-          <a:prstGeom prst="rect">
-            <a:avLst/>
-          </a:prstGeom>
-          <a:solidFill>
-            <a:srgbClr val="C5A35A"/>
+            <a:off x="365760" y="1051560"/>
+            <a:ext cx="5623560" cy="365760"/>
+          </a:xfrm>
+          <a:prstGeom prst="rect">
+            <a:avLst/>
+          </a:prstGeom>
+          <a:solidFill>
+            <a:srgbClr val="0B2C4A"/>
           </a:solidFill>
           <a:ln>
             <a:noFill/>
@@ -19907,8 +20319,8 @@
         </p:nvSpPr>
         <p:spPr>
           <a:xfrm>
-            <a:off x="667512" y="1207008"/>
-            <a:ext cx="5257800" cy="329184"/>
+            <a:off x="365760" y="1051560"/>
+            <a:ext cx="5623560" cy="365760"/>
           </a:xfrm>
           <a:prstGeom prst="rect">
             <a:avLst/>
@@ -19916,57 +20328,46 @@
           <a:noFill/>
         </p:spPr>
         <p:txBody>
-          <a:bodyPr wrap="square" anchor="t"/>
-          <a:lstStyle/>
-          <a:p>
-            <a:pPr algn="l"/>
-            <a:r>
-              <a:rPr sz="1800" b="1">
-                <a:solidFill>
-                  <a:srgbClr val="0B2C4A"/>
-                </a:solidFill>
-                <a:latin typeface="Calibri"/>
-              </a:rPr>
-              <a:t>Cushing  (no L)</a:t>
-            </a:r>
-          </a:p>
-        </p:txBody>
-      </p:sp>
-      <p:sp>
-        <p:nvSpPr>
-          <p:cNvPr id="10" name="TextBox 9"/>
-          <p:cNvSpPr txBox="1"/>
-          <p:nvPr/>
-        </p:nvSpPr>
-        <p:spPr>
-          <a:xfrm>
-            <a:off x="667512" y="1554480"/>
-            <a:ext cx="5257800" cy="4553712"/>
-          </a:xfrm>
-          <a:prstGeom prst="rect">
-            <a:avLst/>
-          </a:prstGeom>
-          <a:noFill/>
-        </p:spPr>
-        <p:txBody>
-          <a:bodyPr wrap="square" anchor="t"/>
-          <a:lstStyle/>
-          <a:p>
-            <a:pPr algn="l"/>
-            <a:r>
-              <a:rPr sz="1600" b="0">
-                <a:solidFill>
-                  <a:srgbClr val="3D4A57"/>
-                </a:solidFill>
-                <a:latin typeface="Calibri"/>
-              </a:rPr>
-              <a:t>Continuous. Inverting. Bites run parallel to the incision.
-Does not enter the lumen. Serosa, muscularis, submucosa only (WCVM).
-Memory: Cushing does not go in.</a:t>
-            </a:r>
-          </a:p>
-        </p:txBody>
-      </p:sp>
+          <a:bodyPr wrap="square" anchor="ctr"/>
+          <a:lstStyle/>
+          <a:p>
+            <a:pPr algn="ctr"/>
+            <a:r>
+              <a:rPr sz="1400" b="1">
+                <a:solidFill>
+                  <a:srgbClr val="C5A35A"/>
+                </a:solidFill>
+                <a:latin typeface="Calibri"/>
+              </a:rPr>
+              <a:t>Cushing  ·  original 3D</a:t>
+            </a:r>
+          </a:p>
+        </p:txBody>
+      </p:sp>
+      <p:pic>
+        <p:nvPicPr>
+          <p:cNvPr id="10" name="Picture 9" descr="suture3d_cushing.png"/>
+          <p:cNvPicPr>
+            <a:picLocks noChangeAspect="1"/>
+          </p:cNvPicPr>
+          <p:nvPr/>
+        </p:nvPicPr>
+        <p:blipFill>
+          <a:blip r:embed="rId2"/>
+          <a:stretch>
+            <a:fillRect/>
+          </a:stretch>
+        </p:blipFill>
+        <p:spPr>
+          <a:xfrm>
+            <a:off x="1708404" y="1508760"/>
+            <a:ext cx="2938272" cy="2203704"/>
+          </a:xfrm>
+          <a:prstGeom prst="rect">
+            <a:avLst/>
+          </a:prstGeom>
+        </p:spPr>
+      </p:pic>
       <p:sp>
         <p:nvSpPr>
           <p:cNvPr id="11" name="Rounded Rectangle 10"/>
@@ -19975,8 +20376,8 @@
         </p:nvSpPr>
         <p:spPr>
           <a:xfrm>
-            <a:off x="6217920" y="1097280"/>
-            <a:ext cx="5532120" cy="5120640"/>
+            <a:off x="6172200" y="1051560"/>
+            <a:ext cx="5577840" cy="2788920"/>
           </a:xfrm>
           <a:prstGeom prst="roundRect">
             <a:avLst>
@@ -20020,8 +20421,8 @@
         </p:nvSpPr>
         <p:spPr>
           <a:xfrm>
-            <a:off x="6217920" y="1097280"/>
-            <a:ext cx="91440" cy="5120640"/>
+            <a:off x="6172200" y="1051560"/>
+            <a:ext cx="5577840" cy="365760"/>
           </a:xfrm>
           <a:prstGeom prst="rect">
             <a:avLst/>
@@ -20063,8 +20464,8 @@
         </p:nvSpPr>
         <p:spPr>
           <a:xfrm>
-            <a:off x="6473952" y="1207008"/>
-            <a:ext cx="5166360" cy="329184"/>
+            <a:off x="6172200" y="1051560"/>
+            <a:ext cx="5577840" cy="365760"/>
           </a:xfrm>
           <a:prstGeom prst="rect">
             <a:avLst/>
@@ -20072,6 +20473,151 @@
           <a:noFill/>
         </p:spPr>
         <p:txBody>
+          <a:bodyPr wrap="square" anchor="ctr"/>
+          <a:lstStyle/>
+          <a:p>
+            <a:pPr algn="ctr"/>
+            <a:r>
+              <a:rPr sz="1400" b="1">
+                <a:solidFill>
+                  <a:srgbClr val="C5A35A"/>
+                </a:solidFill>
+                <a:latin typeface="Calibri"/>
+              </a:rPr>
+              <a:t>Connell  ·  original 3D</a:t>
+            </a:r>
+          </a:p>
+        </p:txBody>
+      </p:sp>
+      <p:pic>
+        <p:nvPicPr>
+          <p:cNvPr id="14" name="Picture 13" descr="suture3d_connell.png"/>
+          <p:cNvPicPr>
+            <a:picLocks noChangeAspect="1"/>
+          </p:cNvPicPr>
+          <p:nvPr/>
+        </p:nvPicPr>
+        <p:blipFill>
+          <a:blip r:embed="rId3"/>
+          <a:stretch>
+            <a:fillRect/>
+          </a:stretch>
+        </p:blipFill>
+        <p:spPr>
+          <a:xfrm>
+            <a:off x="7491984" y="1508760"/>
+            <a:ext cx="2938272" cy="2203704"/>
+          </a:xfrm>
+          <a:prstGeom prst="rect">
+            <a:avLst/>
+          </a:prstGeom>
+        </p:spPr>
+      </p:pic>
+      <p:sp>
+        <p:nvSpPr>
+          <p:cNvPr id="15" name="Rounded Rectangle 14"/>
+          <p:cNvSpPr/>
+          <p:nvPr/>
+        </p:nvSpPr>
+        <p:spPr>
+          <a:xfrm>
+            <a:off x="365760" y="3950208"/>
+            <a:ext cx="5623560" cy="2267712"/>
+          </a:xfrm>
+          <a:prstGeom prst="roundRect">
+            <a:avLst>
+              <a:gd name="adj" fmla="val 8000"/>
+            </a:avLst>
+          </a:prstGeom>
+          <a:solidFill>
+            <a:srgbClr val="FFFFFF"/>
+          </a:solidFill>
+          <a:ln>
+            <a:noFill/>
+          </a:ln>
+        </p:spPr>
+        <p:style>
+          <a:lnRef idx="1">
+            <a:schemeClr val="accent1"/>
+          </a:lnRef>
+          <a:fillRef idx="3">
+            <a:schemeClr val="accent1"/>
+          </a:fillRef>
+          <a:effectRef idx="2">
+            <a:schemeClr val="accent1"/>
+          </a:effectRef>
+          <a:fontRef idx="minor">
+            <a:schemeClr val="lt1"/>
+          </a:fontRef>
+        </p:style>
+        <p:txBody>
+          <a:bodyPr rtlCol="0" anchor="ctr"/>
+          <a:lstStyle/>
+          <a:p>
+            <a:pPr algn="ctr"/>
+          </a:p>
+        </p:txBody>
+      </p:sp>
+      <p:sp>
+        <p:nvSpPr>
+          <p:cNvPr id="16" name="Rectangle 15"/>
+          <p:cNvSpPr/>
+          <p:nvPr/>
+        </p:nvSpPr>
+        <p:spPr>
+          <a:xfrm>
+            <a:off x="365760" y="3950208"/>
+            <a:ext cx="91440" cy="2267712"/>
+          </a:xfrm>
+          <a:prstGeom prst="rect">
+            <a:avLst/>
+          </a:prstGeom>
+          <a:solidFill>
+            <a:srgbClr val="C5A35A"/>
+          </a:solidFill>
+          <a:ln>
+            <a:noFill/>
+          </a:ln>
+        </p:spPr>
+        <p:style>
+          <a:lnRef idx="1">
+            <a:schemeClr val="accent1"/>
+          </a:lnRef>
+          <a:fillRef idx="3">
+            <a:schemeClr val="accent1"/>
+          </a:fillRef>
+          <a:effectRef idx="2">
+            <a:schemeClr val="accent1"/>
+          </a:effectRef>
+          <a:fontRef idx="minor">
+            <a:schemeClr val="lt1"/>
+          </a:fontRef>
+        </p:style>
+        <p:txBody>
+          <a:bodyPr rtlCol="0" anchor="ctr"/>
+          <a:lstStyle/>
+          <a:p>
+            <a:pPr algn="ctr"/>
+          </a:p>
+        </p:txBody>
+      </p:sp>
+      <p:sp>
+        <p:nvSpPr>
+          <p:cNvPr id="17" name="TextBox 16"/>
+          <p:cNvSpPr txBox="1"/>
+          <p:nvPr/>
+        </p:nvSpPr>
+        <p:spPr>
+          <a:xfrm>
+            <a:off x="621792" y="4059936"/>
+            <a:ext cx="5257800" cy="329184"/>
+          </a:xfrm>
+          <a:prstGeom prst="rect">
+            <a:avLst/>
+          </a:prstGeom>
+          <a:noFill/>
+        </p:spPr>
+        <p:txBody>
           <a:bodyPr wrap="square" anchor="t"/>
           <a:lstStyle/>
           <a:p>
@@ -20083,6 +20629,160 @@
                 </a:solidFill>
                 <a:latin typeface="Calibri"/>
               </a:rPr>
+              <a:t>Cushing  (no L)</a:t>
+            </a:r>
+          </a:p>
+        </p:txBody>
+      </p:sp>
+      <p:sp>
+        <p:nvSpPr>
+          <p:cNvPr id="18" name="TextBox 17"/>
+          <p:cNvSpPr txBox="1"/>
+          <p:nvPr/>
+        </p:nvSpPr>
+        <p:spPr>
+          <a:xfrm>
+            <a:off x="621792" y="4407408"/>
+            <a:ext cx="5257800" cy="1700784"/>
+          </a:xfrm>
+          <a:prstGeom prst="rect">
+            <a:avLst/>
+          </a:prstGeom>
+          <a:noFill/>
+        </p:spPr>
+        <p:txBody>
+          <a:bodyPr wrap="square" anchor="t"/>
+          <a:lstStyle/>
+          <a:p>
+            <a:pPr algn="l"/>
+            <a:r>
+              <a:rPr sz="1600" b="0">
+                <a:solidFill>
+                  <a:srgbClr val="3D4A57"/>
+                </a:solidFill>
+                <a:latin typeface="Calibri"/>
+              </a:rPr>
+              <a:t>Continuous. Inverting. Parallel bites. Does not enter the lumen. Serosa, muscularis, submucosa only (WCVM). Memory: Cushing does not go in.</a:t>
+            </a:r>
+          </a:p>
+        </p:txBody>
+      </p:sp>
+      <p:sp>
+        <p:nvSpPr>
+          <p:cNvPr id="19" name="Rounded Rectangle 18"/>
+          <p:cNvSpPr/>
+          <p:nvPr/>
+        </p:nvSpPr>
+        <p:spPr>
+          <a:xfrm>
+            <a:off x="6172200" y="3950208"/>
+            <a:ext cx="5577840" cy="2267712"/>
+          </a:xfrm>
+          <a:prstGeom prst="roundRect">
+            <a:avLst>
+              <a:gd name="adj" fmla="val 8000"/>
+            </a:avLst>
+          </a:prstGeom>
+          <a:solidFill>
+            <a:srgbClr val="FFFFFF"/>
+          </a:solidFill>
+          <a:ln>
+            <a:noFill/>
+          </a:ln>
+        </p:spPr>
+        <p:style>
+          <a:lnRef idx="1">
+            <a:schemeClr val="accent1"/>
+          </a:lnRef>
+          <a:fillRef idx="3">
+            <a:schemeClr val="accent1"/>
+          </a:fillRef>
+          <a:effectRef idx="2">
+            <a:schemeClr val="accent1"/>
+          </a:effectRef>
+          <a:fontRef idx="minor">
+            <a:schemeClr val="lt1"/>
+          </a:fontRef>
+        </p:style>
+        <p:txBody>
+          <a:bodyPr rtlCol="0" anchor="ctr"/>
+          <a:lstStyle/>
+          <a:p>
+            <a:pPr algn="ctr"/>
+          </a:p>
+        </p:txBody>
+      </p:sp>
+      <p:sp>
+        <p:nvSpPr>
+          <p:cNvPr id="20" name="Rectangle 19"/>
+          <p:cNvSpPr/>
+          <p:nvPr/>
+        </p:nvSpPr>
+        <p:spPr>
+          <a:xfrm>
+            <a:off x="6172200" y="3950208"/>
+            <a:ext cx="91440" cy="2267712"/>
+          </a:xfrm>
+          <a:prstGeom prst="rect">
+            <a:avLst/>
+          </a:prstGeom>
+          <a:solidFill>
+            <a:srgbClr val="0B2C4A"/>
+          </a:solidFill>
+          <a:ln>
+            <a:noFill/>
+          </a:ln>
+        </p:spPr>
+        <p:style>
+          <a:lnRef idx="1">
+            <a:schemeClr val="accent1"/>
+          </a:lnRef>
+          <a:fillRef idx="3">
+            <a:schemeClr val="accent1"/>
+          </a:fillRef>
+          <a:effectRef idx="2">
+            <a:schemeClr val="accent1"/>
+          </a:effectRef>
+          <a:fontRef idx="minor">
+            <a:schemeClr val="lt1"/>
+          </a:fontRef>
+        </p:style>
+        <p:txBody>
+          <a:bodyPr rtlCol="0" anchor="ctr"/>
+          <a:lstStyle/>
+          <a:p>
+            <a:pPr algn="ctr"/>
+          </a:p>
+        </p:txBody>
+      </p:sp>
+      <p:sp>
+        <p:nvSpPr>
+          <p:cNvPr id="21" name="TextBox 20"/>
+          <p:cNvSpPr txBox="1"/>
+          <p:nvPr/>
+        </p:nvSpPr>
+        <p:spPr>
+          <a:xfrm>
+            <a:off x="6428232" y="4059936"/>
+            <a:ext cx="5212080" cy="329184"/>
+          </a:xfrm>
+          <a:prstGeom prst="rect">
+            <a:avLst/>
+          </a:prstGeom>
+          <a:noFill/>
+        </p:spPr>
+        <p:txBody>
+          <a:bodyPr wrap="square" anchor="t"/>
+          <a:lstStyle/>
+          <a:p>
+            <a:pPr algn="l"/>
+            <a:r>
+              <a:rPr sz="1800" b="1">
+                <a:solidFill>
+                  <a:srgbClr val="0B2C4A"/>
+                </a:solidFill>
+                <a:latin typeface="Calibri"/>
+              </a:rPr>
               <a:t>Connell  (has L)</a:t>
             </a:r>
           </a:p>
@@ -20090,14 +20790,14 @@
       </p:sp>
       <p:sp>
         <p:nvSpPr>
-          <p:cNvPr id="14" name="TextBox 13"/>
+          <p:cNvPr id="22" name="TextBox 21"/>
           <p:cNvSpPr txBox="1"/>
           <p:nvPr/>
         </p:nvSpPr>
         <p:spPr>
           <a:xfrm>
-            <a:off x="6473952" y="1554480"/>
-            <a:ext cx="5166360" cy="4553712"/>
+            <a:off x="6428232" y="4407408"/>
+            <a:ext cx="5212080" cy="1700784"/>
           </a:xfrm>
           <a:prstGeom prst="rect">
             <a:avLst/>
@@ -20116,17 +20816,14 @@
                 </a:solidFill>
                 <a:latin typeface="Calibri"/>
               </a:rPr>
-              <a:t>Continuous. Inverting. Bites also run parallel.
-Does enter the lumen (WCVM).
-Memory: Connell goes into the lumen. The extra letter is the extra depth.
-More contamination risk. Confirm in Fossum when this is the first layer versus an oversew.</a:t>
-            </a:r>
-          </a:p>
-        </p:txBody>
-      </p:sp>
-      <p:sp>
-        <p:nvSpPr>
-          <p:cNvPr id="15" name="Rectangle 14"/>
+              <a:t>Continuous. Inverting. Parallel bites. Does enter the lumen (WCVM). Memory: Connell goes into the lumen. The extra letter is the extra depth.</a:t>
+            </a:r>
+          </a:p>
+        </p:txBody>
+      </p:sp>
+      <p:sp>
+        <p:nvSpPr>
+          <p:cNvPr id="23" name="Rectangle 22"/>
           <p:cNvSpPr/>
           <p:nvPr/>
         </p:nvSpPr>
@@ -20169,7 +20866,7 @@
       </p:sp>
       <p:sp>
         <p:nvSpPr>
-          <p:cNvPr id="16" name="TextBox 15"/>
+          <p:cNvPr id="24" name="TextBox 23"/>
           <p:cNvSpPr txBox="1"/>
           <p:nvPr/>
         </p:nvSpPr>
@@ -20202,7 +20899,7 @@
       </p:sp>
       <p:sp>
         <p:nvSpPr>
-          <p:cNvPr id="17" name="TextBox 16"/>
+          <p:cNvPr id="25" name="TextBox 24"/>
           <p:cNvSpPr txBox="1"/>
           <p:nvPr/>
         </p:nvSpPr>
@@ -20458,14 +21155,102 @@
       </p:sp>
       <p:sp>
         <p:nvSpPr>
-          <p:cNvPr id="7" name="TextBox 6"/>
+          <p:cNvPr id="7" name="Rounded Rectangle 6"/>
+          <p:cNvSpPr/>
+          <p:nvPr/>
+        </p:nvSpPr>
+        <p:spPr>
+          <a:xfrm>
+            <a:off x="365760" y="1051560"/>
+            <a:ext cx="5212080" cy="5166360"/>
+          </a:xfrm>
+          <a:prstGeom prst="roundRect">
+            <a:avLst>
+              <a:gd name="adj" fmla="val 8000"/>
+            </a:avLst>
+          </a:prstGeom>
+          <a:solidFill>
+            <a:srgbClr val="FFFFFF"/>
+          </a:solidFill>
+          <a:ln>
+            <a:noFill/>
+          </a:ln>
+        </p:spPr>
+        <p:style>
+          <a:lnRef idx="1">
+            <a:schemeClr val="accent1"/>
+          </a:lnRef>
+          <a:fillRef idx="3">
+            <a:schemeClr val="accent1"/>
+          </a:fillRef>
+          <a:effectRef idx="2">
+            <a:schemeClr val="accent1"/>
+          </a:effectRef>
+          <a:fontRef idx="minor">
+            <a:schemeClr val="lt1"/>
+          </a:fontRef>
+        </p:style>
+        <p:txBody>
+          <a:bodyPr rtlCol="0" anchor="ctr"/>
+          <a:lstStyle/>
+          <a:p>
+            <a:pPr algn="ctr"/>
+          </a:p>
+        </p:txBody>
+      </p:sp>
+      <p:sp>
+        <p:nvSpPr>
+          <p:cNvPr id="8" name="Rectangle 7"/>
+          <p:cNvSpPr/>
+          <p:nvPr/>
+        </p:nvSpPr>
+        <p:spPr>
+          <a:xfrm>
+            <a:off x="365760" y="1051560"/>
+            <a:ext cx="5212080" cy="365760"/>
+          </a:xfrm>
+          <a:prstGeom prst="rect">
+            <a:avLst/>
+          </a:prstGeom>
+          <a:solidFill>
+            <a:srgbClr val="0B2C4A"/>
+          </a:solidFill>
+          <a:ln>
+            <a:noFill/>
+          </a:ln>
+        </p:spPr>
+        <p:style>
+          <a:lnRef idx="1">
+            <a:schemeClr val="accent1"/>
+          </a:lnRef>
+          <a:fillRef idx="3">
+            <a:schemeClr val="accent1"/>
+          </a:fillRef>
+          <a:effectRef idx="2">
+            <a:schemeClr val="accent1"/>
+          </a:effectRef>
+          <a:fontRef idx="minor">
+            <a:schemeClr val="lt1"/>
+          </a:fontRef>
+        </p:style>
+        <p:txBody>
+          <a:bodyPr rtlCol="0" anchor="ctr"/>
+          <a:lstStyle/>
+          <a:p>
+            <a:pPr algn="ctr"/>
+          </a:p>
+        </p:txBody>
+      </p:sp>
+      <p:sp>
+        <p:nvSpPr>
+          <p:cNvPr id="9" name="TextBox 8"/>
           <p:cNvSpPr txBox="1"/>
           <p:nvPr/>
         </p:nvSpPr>
         <p:spPr>
           <a:xfrm>
-            <a:off x="502920" y="1143000"/>
-            <a:ext cx="11155680" cy="4937760"/>
+            <a:off x="365760" y="1051560"/>
+            <a:ext cx="5212080" cy="365760"/>
           </a:xfrm>
           <a:prstGeom prst="rect">
             <a:avLst/>
@@ -20473,79 +21258,206 @@
           <a:noFill/>
         </p:spPr>
         <p:txBody>
-          <a:bodyPr wrap="square">
-            <a:spAutoFit/>
-          </a:bodyPr>
-          <a:lstStyle/>
-          <a:p>
-            <a:pPr algn="l">
-              <a:spcAft>
-                <a:spcPts val="1200"/>
-              </a:spcAft>
-            </a:pPr>
-            <a:r>
-              <a:rPr sz="2000">
-                <a:solidFill>
-                  <a:srgbClr val="1C1C1C"/>
-                </a:solidFill>
-                <a:latin typeface="Calibri"/>
-              </a:rPr>
-              <a:t>▸  A purse-string is a circular continuous bite that cinches an opening. Name it. Confirm the organ and the material in Fossum or the lab.</a:t>
-            </a:r>
-          </a:p>
-          <a:p>
-            <a:pPr algn="l">
-              <a:spcAft>
-                <a:spcPts val="1200"/>
-              </a:spcAft>
-            </a:pPr>
-            <a:r>
-              <a:rPr sz="2000">
-                <a:solidFill>
-                  <a:srgbClr val="1C1C1C"/>
-                </a:solidFill>
-                <a:latin typeface="Calibri"/>
-              </a:rPr>
-              <a:t>▸  Parker-Kerr and other oversew names live in the textbook. Do not fake a construction on the board.</a:t>
-            </a:r>
-          </a:p>
-          <a:p>
-            <a:pPr algn="l">
-              <a:spcAft>
-                <a:spcPts val="1200"/>
-              </a:spcAft>
-            </a:pPr>
-            <a:r>
-              <a:rPr sz="2000">
-                <a:solidFill>
-                  <a:srgbClr val="1C1C1C"/>
-                </a:solidFill>
-                <a:latin typeface="Calibri"/>
-              </a:rPr>
-              <a:t>▸  Staples and glue are hospital tools, not this hour’s pattern list.</a:t>
-            </a:r>
-          </a:p>
-          <a:p>
-            <a:pPr algn="l">
-              <a:spcAft>
-                <a:spcPts val="1200"/>
-              </a:spcAft>
-            </a:pPr>
-            <a:r>
-              <a:rPr sz="2000">
-                <a:solidFill>
-                  <a:srgbClr val="1C1C1C"/>
-                </a:solidFill>
-                <a:latin typeface="Calibri"/>
-              </a:rPr>
-              <a:t>▸  If you cannot draw the path of the needle, you do not know the pattern yet.</a:t>
-            </a:r>
-          </a:p>
-        </p:txBody>
-      </p:sp>
-      <p:sp>
-        <p:nvSpPr>
-          <p:cNvPr id="8" name="Rectangle 7"/>
+          <a:bodyPr wrap="square" anchor="ctr"/>
+          <a:lstStyle/>
+          <a:p>
+            <a:pPr algn="ctr"/>
+            <a:r>
+              <a:rPr sz="1400" b="1">
+                <a:solidFill>
+                  <a:srgbClr val="C5A35A"/>
+                </a:solidFill>
+                <a:latin typeface="Calibri"/>
+              </a:rPr>
+              <a:t>Original 3D teaching figure</a:t>
+            </a:r>
+          </a:p>
+        </p:txBody>
+      </p:sp>
+      <p:pic>
+        <p:nvPicPr>
+          <p:cNvPr id="10" name="Picture 9" descr="suture3d_pursestring.png"/>
+          <p:cNvPicPr>
+            <a:picLocks noChangeAspect="1"/>
+          </p:cNvPicPr>
+          <p:nvPr/>
+        </p:nvPicPr>
+        <p:blipFill>
+          <a:blip r:embed="rId2"/>
+          <a:stretch>
+            <a:fillRect/>
+          </a:stretch>
+        </p:blipFill>
+        <p:spPr>
+          <a:xfrm>
+            <a:off x="493776" y="1940814"/>
+            <a:ext cx="4956048" cy="3717036"/>
+          </a:xfrm>
+          <a:prstGeom prst="rect">
+            <a:avLst/>
+          </a:prstGeom>
+        </p:spPr>
+      </p:pic>
+      <p:sp>
+        <p:nvSpPr>
+          <p:cNvPr id="11" name="Rounded Rectangle 10"/>
+          <p:cNvSpPr/>
+          <p:nvPr/>
+        </p:nvSpPr>
+        <p:spPr>
+          <a:xfrm>
+            <a:off x="5760720" y="1051560"/>
+            <a:ext cx="5989320" cy="5166360"/>
+          </a:xfrm>
+          <a:prstGeom prst="roundRect">
+            <a:avLst>
+              <a:gd name="adj" fmla="val 8000"/>
+            </a:avLst>
+          </a:prstGeom>
+          <a:solidFill>
+            <a:srgbClr val="FFFFFF"/>
+          </a:solidFill>
+          <a:ln>
+            <a:noFill/>
+          </a:ln>
+        </p:spPr>
+        <p:style>
+          <a:lnRef idx="1">
+            <a:schemeClr val="accent1"/>
+          </a:lnRef>
+          <a:fillRef idx="3">
+            <a:schemeClr val="accent1"/>
+          </a:fillRef>
+          <a:effectRef idx="2">
+            <a:schemeClr val="accent1"/>
+          </a:effectRef>
+          <a:fontRef idx="minor">
+            <a:schemeClr val="lt1"/>
+          </a:fontRef>
+        </p:style>
+        <p:txBody>
+          <a:bodyPr rtlCol="0" anchor="ctr"/>
+          <a:lstStyle/>
+          <a:p>
+            <a:pPr algn="ctr"/>
+          </a:p>
+        </p:txBody>
+      </p:sp>
+      <p:sp>
+        <p:nvSpPr>
+          <p:cNvPr id="12" name="Rectangle 11"/>
+          <p:cNvSpPr/>
+          <p:nvPr/>
+        </p:nvSpPr>
+        <p:spPr>
+          <a:xfrm>
+            <a:off x="5760720" y="1051560"/>
+            <a:ext cx="91440" cy="5166360"/>
+          </a:xfrm>
+          <a:prstGeom prst="rect">
+            <a:avLst/>
+          </a:prstGeom>
+          <a:solidFill>
+            <a:srgbClr val="C5A35A"/>
+          </a:solidFill>
+          <a:ln>
+            <a:noFill/>
+          </a:ln>
+        </p:spPr>
+        <p:style>
+          <a:lnRef idx="1">
+            <a:schemeClr val="accent1"/>
+          </a:lnRef>
+          <a:fillRef idx="3">
+            <a:schemeClr val="accent1"/>
+          </a:fillRef>
+          <a:effectRef idx="2">
+            <a:schemeClr val="accent1"/>
+          </a:effectRef>
+          <a:fontRef idx="minor">
+            <a:schemeClr val="lt1"/>
+          </a:fontRef>
+        </p:style>
+        <p:txBody>
+          <a:bodyPr rtlCol="0" anchor="ctr"/>
+          <a:lstStyle/>
+          <a:p>
+            <a:pPr algn="ctr"/>
+          </a:p>
+        </p:txBody>
+      </p:sp>
+      <p:sp>
+        <p:nvSpPr>
+          <p:cNvPr id="13" name="TextBox 12"/>
+          <p:cNvSpPr txBox="1"/>
+          <p:nvPr/>
+        </p:nvSpPr>
+        <p:spPr>
+          <a:xfrm>
+            <a:off x="6016752" y="1161288"/>
+            <a:ext cx="5623560" cy="329184"/>
+          </a:xfrm>
+          <a:prstGeom prst="rect">
+            <a:avLst/>
+          </a:prstGeom>
+          <a:noFill/>
+        </p:spPr>
+        <p:txBody>
+          <a:bodyPr wrap="square" anchor="t"/>
+          <a:lstStyle/>
+          <a:p>
+            <a:pPr algn="l"/>
+            <a:r>
+              <a:rPr sz="1800" b="1">
+                <a:solidFill>
+                  <a:srgbClr val="0B2C4A"/>
+                </a:solidFill>
+                <a:latin typeface="Calibri"/>
+              </a:rPr>
+              <a:t>What to say</a:t>
+            </a:r>
+          </a:p>
+        </p:txBody>
+      </p:sp>
+      <p:sp>
+        <p:nvSpPr>
+          <p:cNvPr id="14" name="TextBox 13"/>
+          <p:cNvSpPr txBox="1"/>
+          <p:nvPr/>
+        </p:nvSpPr>
+        <p:spPr>
+          <a:xfrm>
+            <a:off x="6016752" y="1508760"/>
+            <a:ext cx="5623560" cy="4599432"/>
+          </a:xfrm>
+          <a:prstGeom prst="rect">
+            <a:avLst/>
+          </a:prstGeom>
+          <a:noFill/>
+        </p:spPr>
+        <p:txBody>
+          <a:bodyPr wrap="square" anchor="t"/>
+          <a:lstStyle/>
+          <a:p>
+            <a:pPr algn="l"/>
+            <a:r>
+              <a:rPr sz="1600" b="0">
+                <a:solidFill>
+                  <a:srgbClr val="3D4A57"/>
+                </a:solidFill>
+                <a:latin typeface="Calibri"/>
+              </a:rPr>
+              <a:t>A purse-string is a circular continuous bite that cinches an opening. Name it. Confirm the organ and the material in Fossum or the lab.
+Parker-Kerr and other oversew names live in the textbook. Do not fake a construction on the board.
+Staples and glue are hospital tools, not this hour’s pattern list.
+If you cannot draw the path of the needle, you do not know the pattern yet.</a:t>
+            </a:r>
+          </a:p>
+        </p:txBody>
+      </p:sp>
+      <p:sp>
+        <p:nvSpPr>
+          <p:cNvPr id="15" name="Rectangle 14"/>
           <p:cNvSpPr/>
           <p:nvPr/>
         </p:nvSpPr>
@@ -20588,7 +21500,7 @@
       </p:sp>
       <p:sp>
         <p:nvSpPr>
-          <p:cNvPr id="9" name="TextBox 8"/>
+          <p:cNvPr id="16" name="TextBox 15"/>
           <p:cNvSpPr txBox="1"/>
           <p:nvPr/>
         </p:nvSpPr>
@@ -20621,7 +21533,7 @@
       </p:sp>
       <p:sp>
         <p:nvSpPr>
-          <p:cNvPr id="10" name="TextBox 9"/>
+          <p:cNvPr id="17" name="TextBox 16"/>
           <p:cNvSpPr txBox="1"/>
           <p:nvPr/>
         </p:nvSpPr>

</xml_diff>

<commit_message>
Enlarge the Cushing versus Connell 3D figures on the comparison slide.
Co-authored-by: drkimvet <drkimvet@users.noreply.github.com>
</commit_message>
<xml_diff>
--- a/lectures/DVM-612_Week7_Suture_Patterns_Closures.pptx
+++ b/lectures/DVM-612_Week7_Suture_Patterns_Closures.pptx
@@ -20232,7 +20232,7 @@
         <p:spPr>
           <a:xfrm>
             <a:off x="365760" y="1051560"/>
-            <a:ext cx="5623560" cy="2788920"/>
+            <a:ext cx="5623560" cy="3401568"/>
           </a:xfrm>
           <a:prstGeom prst="roundRect">
             <a:avLst>
@@ -20360,8 +20360,8 @@
         </p:blipFill>
         <p:spPr>
           <a:xfrm>
-            <a:off x="1708404" y="1508760"/>
-            <a:ext cx="2938272" cy="2203704"/>
+            <a:off x="1299972" y="1508760"/>
+            <a:ext cx="3755136" cy="2816352"/>
           </a:xfrm>
           <a:prstGeom prst="rect">
             <a:avLst/>
@@ -20377,7 +20377,7 @@
         <p:spPr>
           <a:xfrm>
             <a:off x="6172200" y="1051560"/>
-            <a:ext cx="5577840" cy="2788920"/>
+            <a:ext cx="5577840" cy="3401568"/>
           </a:xfrm>
           <a:prstGeom prst="roundRect">
             <a:avLst>
@@ -20505,8 +20505,8 @@
         </p:blipFill>
         <p:spPr>
           <a:xfrm>
-            <a:off x="7491984" y="1508760"/>
-            <a:ext cx="2938272" cy="2203704"/>
+            <a:off x="7083552" y="1508760"/>
+            <a:ext cx="3755136" cy="2816352"/>
           </a:xfrm>
           <a:prstGeom prst="rect">
             <a:avLst/>
@@ -20521,8 +20521,8 @@
         </p:nvSpPr>
         <p:spPr>
           <a:xfrm>
-            <a:off x="365760" y="3950208"/>
-            <a:ext cx="5623560" cy="2267712"/>
+            <a:off x="365760" y="4553712"/>
+            <a:ext cx="5623560" cy="1664208"/>
           </a:xfrm>
           <a:prstGeom prst="roundRect">
             <a:avLst>
@@ -20566,8 +20566,8 @@
         </p:nvSpPr>
         <p:spPr>
           <a:xfrm>
-            <a:off x="365760" y="3950208"/>
-            <a:ext cx="91440" cy="2267712"/>
+            <a:off x="365760" y="4553712"/>
+            <a:ext cx="91440" cy="1664208"/>
           </a:xfrm>
           <a:prstGeom prst="rect">
             <a:avLst/>
@@ -20609,7 +20609,7 @@
         </p:nvSpPr>
         <p:spPr>
           <a:xfrm>
-            <a:off x="621792" y="4059936"/>
+            <a:off x="621792" y="4663440"/>
             <a:ext cx="5257800" cy="329184"/>
           </a:xfrm>
           <a:prstGeom prst="rect">
@@ -20642,8 +20642,8 @@
         </p:nvSpPr>
         <p:spPr>
           <a:xfrm>
-            <a:off x="621792" y="4407408"/>
-            <a:ext cx="5257800" cy="1700784"/>
+            <a:off x="621792" y="5010912"/>
+            <a:ext cx="5257800" cy="1097280"/>
           </a:xfrm>
           <a:prstGeom prst="rect">
             <a:avLst/>
@@ -20662,7 +20662,7 @@
                 </a:solidFill>
                 <a:latin typeface="Calibri"/>
               </a:rPr>
-              <a:t>Continuous. Inverting. Parallel bites. Does not enter the lumen. Serosa, muscularis, submucosa only (WCVM). Memory: Cushing does not go in.</a:t>
+              <a:t>Continuous. Inverting. Parallel bites. Does not enter the lumen (WCVM). Memory: Cushing does not go in.</a:t>
             </a:r>
           </a:p>
         </p:txBody>
@@ -20675,8 +20675,8 @@
         </p:nvSpPr>
         <p:spPr>
           <a:xfrm>
-            <a:off x="6172200" y="3950208"/>
-            <a:ext cx="5577840" cy="2267712"/>
+            <a:off x="6172200" y="4553712"/>
+            <a:ext cx="5577840" cy="1664208"/>
           </a:xfrm>
           <a:prstGeom prst="roundRect">
             <a:avLst>
@@ -20720,8 +20720,8 @@
         </p:nvSpPr>
         <p:spPr>
           <a:xfrm>
-            <a:off x="6172200" y="3950208"/>
-            <a:ext cx="91440" cy="2267712"/>
+            <a:off x="6172200" y="4553712"/>
+            <a:ext cx="91440" cy="1664208"/>
           </a:xfrm>
           <a:prstGeom prst="rect">
             <a:avLst/>
@@ -20763,7 +20763,7 @@
         </p:nvSpPr>
         <p:spPr>
           <a:xfrm>
-            <a:off x="6428232" y="4059936"/>
+            <a:off x="6428232" y="4663440"/>
             <a:ext cx="5212080" cy="329184"/>
           </a:xfrm>
           <a:prstGeom prst="rect">
@@ -20796,8 +20796,8 @@
         </p:nvSpPr>
         <p:spPr>
           <a:xfrm>
-            <a:off x="6428232" y="4407408"/>
-            <a:ext cx="5212080" cy="1700784"/>
+            <a:off x="6428232" y="5010912"/>
+            <a:ext cx="5212080" cy="1097280"/>
           </a:xfrm>
           <a:prstGeom prst="rect">
             <a:avLst/>
@@ -20816,7 +20816,7 @@
                 </a:solidFill>
                 <a:latin typeface="Calibri"/>
               </a:rPr>
-              <a:t>Continuous. Inverting. Parallel bites. Does enter the lumen (WCVM). Memory: Connell goes into the lumen. The extra letter is the extra depth.</a:t>
+              <a:t>Continuous. Inverting. Parallel bites. Does enter the lumen (WCVM). Memory: Connell goes into the lumen.</a:t>
             </a:r>
           </a:p>
         </p:txBody>

</xml_diff>